<commit_message>
docs: add portable HTML workshop materials
Co-authored-by: Copilot <223556219+Copilot@users.noreply.github.com>
</commit_message>
<xml_diff>
--- a/docs/rapp-workshop/downloads/FY27 RAPP Workshop Deck.pptx
+++ b/docs/rapp-workshop/downloads/FY27 RAPP Workshop Deck.pptx
@@ -4,9 +4,6 @@
   <p:sldMasterIdLst>
     <p:sldMasterId id="2147483648" r:id="rId1"/>
   </p:sldMasterIdLst>
-  <p:notesMasterIdLst>
-    <p:notesMasterId r:id="rId24"/>
-  </p:notesMasterIdLst>
   <p:sldIdLst>
     <p:sldId id="256" r:id="rId2"/>
     <p:sldId id="257" r:id="rId3"/>
@@ -128,2333 +125,6 @@
 </p:presentation>
 </file>
 
-<file path=ppt/notesMasters/notesMaster1.xml><?xml version="1.0" encoding="utf-8"?>
-<p:notesMaster xmlns:a="http://schemas.openxmlformats.org/drawingml/2006/main" xmlns:r="http://schemas.openxmlformats.org/officeDocument/2006/relationships" xmlns:p="http://schemas.openxmlformats.org/presentationml/2006/main">
-  <p:cSld>
-    <p:bg>
-      <p:bgRef idx="1001">
-        <a:schemeClr val="bg1"/>
-      </p:bgRef>
-    </p:bg>
-    <p:spTree>
-      <p:nvGrpSpPr>
-        <p:cNvPr id="1" name=""/>
-        <p:cNvGrpSpPr/>
-        <p:nvPr/>
-      </p:nvGrpSpPr>
-      <p:grpSpPr>
-        <a:xfrm>
-          <a:off x="0" y="0"/>
-          <a:ext cx="0" cy="0"/>
-          <a:chOff x="0" y="0"/>
-          <a:chExt cx="0" cy="0"/>
-        </a:xfrm>
-      </p:grpSpPr>
-      <p:sp>
-        <p:nvSpPr>
-          <p:cNvPr id="2" name="Header Placeholder 1"/>
-          <p:cNvSpPr>
-            <a:spLocks noGrp="1"/>
-          </p:cNvSpPr>
-          <p:nvPr>
-            <p:ph type="hdr" sz="quarter"/>
-          </p:nvPr>
-        </p:nvSpPr>
-        <p:spPr>
-          <a:xfrm>
-            <a:off x="0" y="0"/>
-            <a:ext cx="2971800" cy="458788"/>
-          </a:xfrm>
-          <a:prstGeom prst="rect">
-            <a:avLst/>
-          </a:prstGeom>
-        </p:spPr>
-        <p:txBody>
-          <a:bodyPr vert="horz" lIns="91440" tIns="45720" rIns="91440" bIns="45720" rtlCol="0"/>
-          <a:lstStyle>
-            <a:lvl1pPr algn="l">
-              <a:defRPr sz="1200"/>
-            </a:lvl1pPr>
-          </a:lstStyle>
-          <a:p>
-            <a:endParaRPr lang="en-US"/>
-          </a:p>
-        </p:txBody>
-      </p:sp>
-      <p:sp>
-        <p:nvSpPr>
-          <p:cNvPr id="3" name="Date Placeholder 2"/>
-          <p:cNvSpPr>
-            <a:spLocks noGrp="1"/>
-          </p:cNvSpPr>
-          <p:nvPr>
-            <p:ph type="dt" idx="1"/>
-          </p:nvPr>
-        </p:nvSpPr>
-        <p:spPr>
-          <a:xfrm>
-            <a:off x="3884613" y="0"/>
-            <a:ext cx="2971800" cy="458788"/>
-          </a:xfrm>
-          <a:prstGeom prst="rect">
-            <a:avLst/>
-          </a:prstGeom>
-        </p:spPr>
-        <p:txBody>
-          <a:bodyPr vert="horz" lIns="91440" tIns="45720" rIns="91440" bIns="45720" rtlCol="0"/>
-          <a:lstStyle>
-            <a:lvl1pPr algn="r">
-              <a:defRPr sz="1200"/>
-            </a:lvl1pPr>
-          </a:lstStyle>
-          <a:p>
-            <a:fld id="{5282F153-3F37-0F45-9E97-73ACFA13230C}" type="datetimeFigureOut">
-              <a:rPr lang="en-US"/>
-              <a:t>7/23/19</a:t>
-            </a:fld>
-            <a:endParaRPr lang="en-US"/>
-          </a:p>
-        </p:txBody>
-      </p:sp>
-      <p:sp>
-        <p:nvSpPr>
-          <p:cNvPr id="4" name="Slide Image Placeholder 3"/>
-          <p:cNvSpPr>
-            <a:spLocks noGrp="1" noRot="1" noChangeAspect="1"/>
-          </p:cNvSpPr>
-          <p:nvPr>
-            <p:ph type="sldImg" idx="2"/>
-          </p:nvPr>
-        </p:nvSpPr>
-        <p:spPr>
-          <a:xfrm>
-            <a:off x="685800" y="1143000"/>
-            <a:ext cx="5486400" cy="3086100"/>
-          </a:xfrm>
-          <a:prstGeom prst="rect">
-            <a:avLst/>
-          </a:prstGeom>
-          <a:noFill/>
-          <a:ln w="12700">
-            <a:solidFill>
-              <a:prstClr val="black"/>
-            </a:solidFill>
-          </a:ln>
-        </p:spPr>
-        <p:txBody>
-          <a:bodyPr vert="horz" lIns="91440" tIns="45720" rIns="91440" bIns="45720" rtlCol="0" anchor="ctr"/>
-          <a:lstStyle/>
-          <a:p>
-            <a:endParaRPr lang="en-US"/>
-          </a:p>
-        </p:txBody>
-      </p:sp>
-      <p:sp>
-        <p:nvSpPr>
-          <p:cNvPr id="5" name="Notes Placeholder 4"/>
-          <p:cNvSpPr>
-            <a:spLocks noGrp="1"/>
-          </p:cNvSpPr>
-          <p:nvPr>
-            <p:ph type="body" sz="quarter" idx="3"/>
-          </p:nvPr>
-        </p:nvSpPr>
-        <p:spPr>
-          <a:xfrm>
-            <a:off x="685800" y="4400550"/>
-            <a:ext cx="5486400" cy="3600450"/>
-          </a:xfrm>
-          <a:prstGeom prst="rect">
-            <a:avLst/>
-          </a:prstGeom>
-        </p:spPr>
-        <p:txBody>
-          <a:bodyPr vert="horz" lIns="91440" tIns="45720" rIns="91440" bIns="45720" rtlCol="0"/>
-          <a:lstStyle/>
-          <a:p>
-            <a:pPr lvl="0"/>
-            <a:r>
-              <a:rPr lang="en-US"/>
-              <a:t>Click to edit Master text styles</a:t>
-            </a:r>
-          </a:p>
-          <a:p>
-            <a:pPr lvl="1"/>
-            <a:r>
-              <a:rPr lang="en-US"/>
-              <a:t>Second level</a:t>
-            </a:r>
-          </a:p>
-          <a:p>
-            <a:pPr lvl="2"/>
-            <a:r>
-              <a:rPr lang="en-US"/>
-              <a:t>Third level</a:t>
-            </a:r>
-          </a:p>
-          <a:p>
-            <a:pPr lvl="3"/>
-            <a:r>
-              <a:rPr lang="en-US"/>
-              <a:t>Fourth level</a:t>
-            </a:r>
-          </a:p>
-          <a:p>
-            <a:pPr lvl="4"/>
-            <a:r>
-              <a:rPr lang="en-US"/>
-              <a:t>Fifth level</a:t>
-            </a:r>
-          </a:p>
-        </p:txBody>
-      </p:sp>
-      <p:sp>
-        <p:nvSpPr>
-          <p:cNvPr id="6" name="Footer Placeholder 5"/>
-          <p:cNvSpPr>
-            <a:spLocks noGrp="1"/>
-          </p:cNvSpPr>
-          <p:nvPr>
-            <p:ph type="ftr" sz="quarter" idx="4"/>
-          </p:nvPr>
-        </p:nvSpPr>
-        <p:spPr>
-          <a:xfrm>
-            <a:off x="0" y="8685213"/>
-            <a:ext cx="2971800" cy="458787"/>
-          </a:xfrm>
-          <a:prstGeom prst="rect">
-            <a:avLst/>
-          </a:prstGeom>
-        </p:spPr>
-        <p:txBody>
-          <a:bodyPr vert="horz" lIns="91440" tIns="45720" rIns="91440" bIns="45720" rtlCol="0" anchor="b"/>
-          <a:lstStyle>
-            <a:lvl1pPr algn="l">
-              <a:defRPr sz="1200"/>
-            </a:lvl1pPr>
-          </a:lstStyle>
-          <a:p>
-            <a:endParaRPr lang="en-US"/>
-          </a:p>
-        </p:txBody>
-      </p:sp>
-      <p:sp>
-        <p:nvSpPr>
-          <p:cNvPr id="7" name="Slide Number Placeholder 6"/>
-          <p:cNvSpPr>
-            <a:spLocks noGrp="1"/>
-          </p:cNvSpPr>
-          <p:nvPr>
-            <p:ph type="sldNum" sz="quarter" idx="5"/>
-          </p:nvPr>
-        </p:nvSpPr>
-        <p:spPr>
-          <a:xfrm>
-            <a:off x="3884613" y="8685213"/>
-            <a:ext cx="2971800" cy="458787"/>
-          </a:xfrm>
-          <a:prstGeom prst="rect">
-            <a:avLst/>
-          </a:prstGeom>
-        </p:spPr>
-        <p:txBody>
-          <a:bodyPr vert="horz" lIns="91440" tIns="45720" rIns="91440" bIns="45720" rtlCol="0" anchor="b"/>
-          <a:lstStyle>
-            <a:lvl1pPr algn="r">
-              <a:defRPr sz="1200"/>
-            </a:lvl1pPr>
-          </a:lstStyle>
-          <a:p>
-            <a:fld id="{CE5E9CC1-C706-0F49-92D6-E571CC5EEA8F}" type="slidenum">
-              <a:rPr lang="en-US"/>
-              <a:t>‹#›</a:t>
-            </a:fld>
-            <a:endParaRPr lang="en-US"/>
-          </a:p>
-        </p:txBody>
-      </p:sp>
-    </p:spTree>
-    <p:extLst>
-      <p:ext uri="{BB962C8B-B14F-4D97-AF65-F5344CB8AC3E}">
-        <p14:creationId xmlns:p14="http://schemas.microsoft.com/office/powerpoint/2010/main" val="1024086991"/>
-      </p:ext>
-    </p:extLst>
-  </p:cSld>
-  <p:clrMap bg1="lt1" tx1="dk1" bg2="lt2" tx2="dk2" accent1="accent1" accent2="accent2" accent3="accent3" accent4="accent4" accent5="accent5" accent6="accent6" hlink="hlink" folHlink="folHlink"/>
-  <p:notesStyle>
-    <a:lvl1pPr marL="0" algn="l" defTabSz="914400" rtl="0" eaLnBrk="1" latinLnBrk="0" hangingPunct="1">
-      <a:defRPr sz="1200" kern="1200">
-        <a:solidFill>
-          <a:schemeClr val="tx1"/>
-        </a:solidFill>
-        <a:latin typeface="+mn-lt"/>
-        <a:ea typeface="+mn-ea"/>
-        <a:cs typeface="+mn-cs"/>
-      </a:defRPr>
-    </a:lvl1pPr>
-    <a:lvl2pPr marL="457200" algn="l" defTabSz="914400" rtl="0" eaLnBrk="1" latinLnBrk="0" hangingPunct="1">
-      <a:defRPr sz="1200" kern="1200">
-        <a:solidFill>
-          <a:schemeClr val="tx1"/>
-        </a:solidFill>
-        <a:latin typeface="+mn-lt"/>
-        <a:ea typeface="+mn-ea"/>
-        <a:cs typeface="+mn-cs"/>
-      </a:defRPr>
-    </a:lvl2pPr>
-    <a:lvl3pPr marL="914400" algn="l" defTabSz="914400" rtl="0" eaLnBrk="1" latinLnBrk="0" hangingPunct="1">
-      <a:defRPr sz="1200" kern="1200">
-        <a:solidFill>
-          <a:schemeClr val="tx1"/>
-        </a:solidFill>
-        <a:latin typeface="+mn-lt"/>
-        <a:ea typeface="+mn-ea"/>
-        <a:cs typeface="+mn-cs"/>
-      </a:defRPr>
-    </a:lvl3pPr>
-    <a:lvl4pPr marL="1371600" algn="l" defTabSz="914400" rtl="0" eaLnBrk="1" latinLnBrk="0" hangingPunct="1">
-      <a:defRPr sz="1200" kern="1200">
-        <a:solidFill>
-          <a:schemeClr val="tx1"/>
-        </a:solidFill>
-        <a:latin typeface="+mn-lt"/>
-        <a:ea typeface="+mn-ea"/>
-        <a:cs typeface="+mn-cs"/>
-      </a:defRPr>
-    </a:lvl4pPr>
-    <a:lvl5pPr marL="1828800" algn="l" defTabSz="914400" rtl="0" eaLnBrk="1" latinLnBrk="0" hangingPunct="1">
-      <a:defRPr sz="1200" kern="1200">
-        <a:solidFill>
-          <a:schemeClr val="tx1"/>
-        </a:solidFill>
-        <a:latin typeface="+mn-lt"/>
-        <a:ea typeface="+mn-ea"/>
-        <a:cs typeface="+mn-cs"/>
-      </a:defRPr>
-    </a:lvl5pPr>
-    <a:lvl6pPr marL="2286000" algn="l" defTabSz="914400" rtl="0" eaLnBrk="1" latinLnBrk="0" hangingPunct="1">
-      <a:defRPr sz="1200" kern="1200">
-        <a:solidFill>
-          <a:schemeClr val="tx1"/>
-        </a:solidFill>
-        <a:latin typeface="+mn-lt"/>
-        <a:ea typeface="+mn-ea"/>
-        <a:cs typeface="+mn-cs"/>
-      </a:defRPr>
-    </a:lvl6pPr>
-    <a:lvl7pPr marL="2743200" algn="l" defTabSz="914400" rtl="0" eaLnBrk="1" latinLnBrk="0" hangingPunct="1">
-      <a:defRPr sz="1200" kern="1200">
-        <a:solidFill>
-          <a:schemeClr val="tx1"/>
-        </a:solidFill>
-        <a:latin typeface="+mn-lt"/>
-        <a:ea typeface="+mn-ea"/>
-        <a:cs typeface="+mn-cs"/>
-      </a:defRPr>
-    </a:lvl7pPr>
-    <a:lvl8pPr marL="3200400" algn="l" defTabSz="914400" rtl="0" eaLnBrk="1" latinLnBrk="0" hangingPunct="1">
-      <a:defRPr sz="1200" kern="1200">
-        <a:solidFill>
-          <a:schemeClr val="tx1"/>
-        </a:solidFill>
-        <a:latin typeface="+mn-lt"/>
-        <a:ea typeface="+mn-ea"/>
-        <a:cs typeface="+mn-cs"/>
-      </a:defRPr>
-    </a:lvl8pPr>
-    <a:lvl9pPr marL="3657600" algn="l" defTabSz="914400" rtl="0" eaLnBrk="1" latinLnBrk="0" hangingPunct="1">
-      <a:defRPr sz="1200" kern="1200">
-        <a:solidFill>
-          <a:schemeClr val="tx1"/>
-        </a:solidFill>
-        <a:latin typeface="+mn-lt"/>
-        <a:ea typeface="+mn-ea"/>
-        <a:cs typeface="+mn-cs"/>
-      </a:defRPr>
-    </a:lvl9pPr>
-  </p:notesStyle>
-</p:notesMaster>
-</file>
-
-<file path=ppt/notesSlides/notesSlide1.xml><?xml version="1.0" encoding="utf-8"?>
-<p:notes xmlns:a="http://schemas.openxmlformats.org/drawingml/2006/main" xmlns:r="http://schemas.openxmlformats.org/officeDocument/2006/relationships" xmlns:p="http://schemas.openxmlformats.org/presentationml/2006/main">
-  <p:cSld>
-    <p:spTree>
-      <p:nvGrpSpPr>
-        <p:cNvPr id="1" name=""/>
-        <p:cNvGrpSpPr/>
-        <p:nvPr/>
-      </p:nvGrpSpPr>
-      <p:grpSpPr>
-        <a:xfrm>
-          <a:off x="0" y="0"/>
-          <a:ext cx="0" cy="0"/>
-          <a:chOff x="0" y="0"/>
-          <a:chExt cx="0" cy="0"/>
-        </a:xfrm>
-      </p:grpSpPr>
-      <p:sp>
-        <p:nvSpPr>
-          <p:cNvPr id="2" name="Slide Image Placeholder 1"/>
-          <p:cNvSpPr>
-            <a:spLocks noGrp="1" noRot="1" noChangeAspect="1"/>
-          </p:cNvSpPr>
-          <p:nvPr>
-            <p:ph type="sldImg"/>
-          </p:nvPr>
-        </p:nvSpPr>
-        <p:spPr/>
-      </p:sp>
-      <p:sp>
-        <p:nvSpPr>
-          <p:cNvPr id="3" name="Notes Placeholder 2"/>
-          <p:cNvSpPr>
-            <a:spLocks noGrp="1"/>
-          </p:cNvSpPr>
-          <p:nvPr>
-            <p:ph type="body" idx="1"/>
-          </p:nvPr>
-        </p:nvSpPr>
-        <p:spPr/>
-        <p:txBody>
-          <a:bodyPr/>
-          <a:lstStyle/>
-          <a:p>
-            <a:r>
-              <a:rPr lang="en-US" dirty="0"/>
-              <a:t>TIME 0:00-0:01
-FACILITATOR: Welcome participants and set the promise: this is a build-along, not a product lecture. By the end of the hour, the room will have converted a source document into a Copilot Studio solution and tested the resulting agent.
-SAY: For this workshop, RAPP means the guided Documents to Copilot Studio process.</a:t>
-            </a:r>
-            <a:endParaRPr lang="en-US" dirty="0"/>
-          </a:p>
-        </p:txBody>
-      </p:sp>
-      <p:sp>
-        <p:nvSpPr>
-          <p:cNvPr id="4" name="Slide Number Placeholder 3"/>
-          <p:cNvSpPr>
-            <a:spLocks noGrp="1"/>
-          </p:cNvSpPr>
-          <p:nvPr>
-            <p:ph type="sldNum" sz="quarter" idx="10"/>
-          </p:nvPr>
-        </p:nvSpPr>
-        <p:spPr/>
-        <p:txBody>
-          <a:bodyPr/>
-          <a:lstStyle/>
-          <a:p>
-            <a:fld id="{F7021451-1387-4CA6-816F-3879F97B5CBC}" type="slidenum">
-              <a:rPr lang="en-US"/>
-              <a:t>1</a:t>
-            </a:fld>
-            <a:endParaRPr lang="en-US"/>
-          </a:p>
-        </p:txBody>
-      </p:sp>
-    </p:spTree>
-    <p:extLst>
-      <p:ext uri="{BB962C8B-B14F-4D97-AF65-F5344CB8AC3E}">
-        <p14:creationId xmlns:p14="http://schemas.microsoft.com/office/powerpoint/2010/main" val="1024086991"/>
-      </p:ext>
-    </p:extLst>
-  </p:cSld>
-  <p:clrMapOvr>
-    <a:masterClrMapping/>
-  </p:clrMapOvr>
-</p:notes>
-</file>
-
-<file path=ppt/notesSlides/notesSlide10.xml><?xml version="1.0" encoding="utf-8"?>
-<p:notes xmlns:a="http://schemas.openxmlformats.org/drawingml/2006/main" xmlns:r="http://schemas.openxmlformats.org/officeDocument/2006/relationships" xmlns:p="http://schemas.openxmlformats.org/presentationml/2006/main">
-  <p:cSld>
-    <p:spTree>
-      <p:nvGrpSpPr>
-        <p:cNvPr id="1" name=""/>
-        <p:cNvGrpSpPr/>
-        <p:nvPr/>
-      </p:nvGrpSpPr>
-      <p:grpSpPr>
-        <a:xfrm>
-          <a:off x="0" y="0"/>
-          <a:ext cx="0" cy="0"/>
-          <a:chOff x="0" y="0"/>
-          <a:chExt cx="0" cy="0"/>
-        </a:xfrm>
-      </p:grpSpPr>
-      <p:sp>
-        <p:nvSpPr>
-          <p:cNvPr id="2" name="Slide Image Placeholder 1"/>
-          <p:cNvSpPr>
-            <a:spLocks noGrp="1" noRot="1" noChangeAspect="1"/>
-          </p:cNvSpPr>
-          <p:nvPr>
-            <p:ph type="sldImg"/>
-          </p:nvPr>
-        </p:nvSpPr>
-        <p:spPr/>
-      </p:sp>
-      <p:sp>
-        <p:nvSpPr>
-          <p:cNvPr id="3" name="Notes Placeholder 2"/>
-          <p:cNvSpPr>
-            <a:spLocks noGrp="1"/>
-          </p:cNvSpPr>
-          <p:nvPr>
-            <p:ph type="body" idx="1"/>
-          </p:nvPr>
-        </p:nvSpPr>
-        <p:spPr/>
-        <p:txBody>
-          <a:bodyPr/>
-          <a:lstStyle/>
-          <a:p>
-            <a:r>
-              <a:rPr lang="en-US" dirty="0"/>
-              <a:t>TIME 0:26-0:34
-FACILITATOR: Pause the room. Have one participant read the derived MVP aloud. Compare it with the source scenario and edit anything inaccurate. Use Re-derive only when the source changed materially.
-DECISION: Confirm only when the MVP names the user, problem, priority capabilities, and safety boundary. The confirmed title and statement anchor capability generation.</a:t>
-            </a:r>
-            <a:endParaRPr lang="en-US" dirty="0"/>
-          </a:p>
-        </p:txBody>
-      </p:sp>
-      <p:sp>
-        <p:nvSpPr>
-          <p:cNvPr id="4" name="Slide Number Placeholder 3"/>
-          <p:cNvSpPr>
-            <a:spLocks noGrp="1"/>
-          </p:cNvSpPr>
-          <p:nvPr>
-            <p:ph type="sldNum" sz="quarter" idx="10"/>
-          </p:nvPr>
-        </p:nvSpPr>
-        <p:spPr/>
-        <p:txBody>
-          <a:bodyPr/>
-          <a:lstStyle/>
-          <a:p>
-            <a:fld id="{F7021451-1387-4CA6-816F-3879F97B5CBC}" type="slidenum">
-              <a:rPr lang="en-US"/>
-              <a:t>10</a:t>
-            </a:fld>
-            <a:endParaRPr lang="en-US"/>
-          </a:p>
-        </p:txBody>
-      </p:sp>
-    </p:spTree>
-    <p:extLst>
-      <p:ext uri="{BB962C8B-B14F-4D97-AF65-F5344CB8AC3E}">
-        <p14:creationId xmlns:p14="http://schemas.microsoft.com/office/powerpoint/2010/main" val="1024086991"/>
-      </p:ext>
-    </p:extLst>
-  </p:cSld>
-  <p:clrMapOvr>
-    <a:masterClrMapping/>
-  </p:clrMapOvr>
-</p:notes>
-</file>
-
-<file path=ppt/notesSlides/notesSlide11.xml><?xml version="1.0" encoding="utf-8"?>
-<p:notes xmlns:a="http://schemas.openxmlformats.org/drawingml/2006/main" xmlns:r="http://schemas.openxmlformats.org/officeDocument/2006/relationships" xmlns:p="http://schemas.openxmlformats.org/presentationml/2006/main">
-  <p:cSld>
-    <p:spTree>
-      <p:nvGrpSpPr>
-        <p:cNvPr id="1" name=""/>
-        <p:cNvGrpSpPr/>
-        <p:nvPr/>
-      </p:nvGrpSpPr>
-      <p:grpSpPr>
-        <a:xfrm>
-          <a:off x="0" y="0"/>
-          <a:ext cx="0" cy="0"/>
-          <a:chOff x="0" y="0"/>
-          <a:chExt cx="0" cy="0"/>
-        </a:xfrm>
-      </p:grpSpPr>
-      <p:sp>
-        <p:nvSpPr>
-          <p:cNvPr id="2" name="Slide Image Placeholder 1"/>
-          <p:cNvSpPr>
-            <a:spLocks noGrp="1" noRot="1" noChangeAspect="1"/>
-          </p:cNvSpPr>
-          <p:nvPr>
-            <p:ph type="sldImg"/>
-          </p:nvPr>
-        </p:nvSpPr>
-        <p:spPr/>
-      </p:sp>
-      <p:sp>
-        <p:nvSpPr>
-          <p:cNvPr id="3" name="Notes Placeholder 2"/>
-          <p:cNvSpPr>
-            <a:spLocks noGrp="1"/>
-          </p:cNvSpPr>
-          <p:nvPr>
-            <p:ph type="body" idx="1"/>
-          </p:nvPr>
-        </p:nvSpPr>
-        <p:spPr/>
-        <p:txBody>
-          <a:bodyPr/>
-          <a:lstStyle/>
-          <a:p>
-            <a:r>
-              <a:rPr lang="en-US" dirty="0"/>
-              <a:t>TIME 0:34-0:39
-FACILITATOR: Start generation and narrate the progress stages: capability distillation, one portable agent file per capability, and Copilot Studio solution packaging.
-WATCH FOR: A capability count that is too high usually means the source contains future-state ideas. Return to the MVP and narrow it rather than accepting everything.</a:t>
-            </a:r>
-            <a:endParaRPr lang="en-US" dirty="0"/>
-          </a:p>
-        </p:txBody>
-      </p:sp>
-      <p:sp>
-        <p:nvSpPr>
-          <p:cNvPr id="4" name="Slide Number Placeholder 3"/>
-          <p:cNvSpPr>
-            <a:spLocks noGrp="1"/>
-          </p:cNvSpPr>
-          <p:nvPr>
-            <p:ph type="sldNum" sz="quarter" idx="10"/>
-          </p:nvPr>
-        </p:nvSpPr>
-        <p:spPr/>
-        <p:txBody>
-          <a:bodyPr/>
-          <a:lstStyle/>
-          <a:p>
-            <a:fld id="{F7021451-1387-4CA6-816F-3879F97B5CBC}" type="slidenum">
-              <a:rPr lang="en-US"/>
-              <a:t>11</a:t>
-            </a:fld>
-            <a:endParaRPr lang="en-US"/>
-          </a:p>
-        </p:txBody>
-      </p:sp>
-    </p:spTree>
-    <p:extLst>
-      <p:ext uri="{BB962C8B-B14F-4D97-AF65-F5344CB8AC3E}">
-        <p14:creationId xmlns:p14="http://schemas.microsoft.com/office/powerpoint/2010/main" val="1024086991"/>
-      </p:ext>
-    </p:extLst>
-  </p:cSld>
-  <p:clrMapOvr>
-    <a:masterClrMapping/>
-  </p:clrMapOvr>
-</p:notes>
-</file>
-
-<file path=ppt/notesSlides/notesSlide12.xml><?xml version="1.0" encoding="utf-8"?>
-<p:notes xmlns:a="http://schemas.openxmlformats.org/drawingml/2006/main" xmlns:r="http://schemas.openxmlformats.org/officeDocument/2006/relationships" xmlns:p="http://schemas.openxmlformats.org/presentationml/2006/main">
-  <p:cSld>
-    <p:spTree>
-      <p:nvGrpSpPr>
-        <p:cNvPr id="1" name=""/>
-        <p:cNvGrpSpPr/>
-        <p:nvPr/>
-      </p:nvGrpSpPr>
-      <p:grpSpPr>
-        <a:xfrm>
-          <a:off x="0" y="0"/>
-          <a:ext cx="0" cy="0"/>
-          <a:chOff x="0" y="0"/>
-          <a:chExt cx="0" cy="0"/>
-        </a:xfrm>
-      </p:grpSpPr>
-      <p:sp>
-        <p:nvSpPr>
-          <p:cNvPr id="2" name="Slide Image Placeholder 1"/>
-          <p:cNvSpPr>
-            <a:spLocks noGrp="1" noRot="1" noChangeAspect="1"/>
-          </p:cNvSpPr>
-          <p:nvPr>
-            <p:ph type="sldImg"/>
-          </p:nvPr>
-        </p:nvSpPr>
-        <p:spPr/>
-      </p:sp>
-      <p:sp>
-        <p:nvSpPr>
-          <p:cNvPr id="3" name="Notes Placeholder 2"/>
-          <p:cNvSpPr>
-            <a:spLocks noGrp="1"/>
-          </p:cNvSpPr>
-          <p:nvPr>
-            <p:ph type="body" idx="1"/>
-          </p:nvPr>
-        </p:nvSpPr>
-        <p:spPr/>
-        <p:txBody>
-          <a:bodyPr/>
-          <a:lstStyle/>
-          <a:p>
-            <a:r>
-              <a:rPr lang="en-US" dirty="0"/>
-              <a:t>TIME 0:39-0:44
-FACILITATOR: Compare the twins. The demo twin uses synthetic data and zero connections so it can be tested immediately. The live prototype carries real connector steps and may require connection-reference binding after import.
-DECISION: Review capability names, source systems, write actions, and generated files. Do not proceed if the generated scope does not match the confirmed MVP.</a:t>
-            </a:r>
-            <a:endParaRPr lang="en-US" dirty="0"/>
-          </a:p>
-        </p:txBody>
-      </p:sp>
-      <p:sp>
-        <p:nvSpPr>
-          <p:cNvPr id="4" name="Slide Number Placeholder 3"/>
-          <p:cNvSpPr>
-            <a:spLocks noGrp="1"/>
-          </p:cNvSpPr>
-          <p:nvPr>
-            <p:ph type="sldNum" sz="quarter" idx="10"/>
-          </p:nvPr>
-        </p:nvSpPr>
-        <p:spPr/>
-        <p:txBody>
-          <a:bodyPr/>
-          <a:lstStyle/>
-          <a:p>
-            <a:fld id="{F7021451-1387-4CA6-816F-3879F97B5CBC}" type="slidenum">
-              <a:rPr lang="en-US"/>
-              <a:t>12</a:t>
-            </a:fld>
-            <a:endParaRPr lang="en-US"/>
-          </a:p>
-        </p:txBody>
-      </p:sp>
-    </p:spTree>
-    <p:extLst>
-      <p:ext uri="{BB962C8B-B14F-4D97-AF65-F5344CB8AC3E}">
-        <p14:creationId xmlns:p14="http://schemas.microsoft.com/office/powerpoint/2010/main" val="1024086991"/>
-      </p:ext>
-    </p:extLst>
-  </p:cSld>
-  <p:clrMapOvr>
-    <a:masterClrMapping/>
-  </p:clrMapOvr>
-</p:notes>
-</file>
-
-<file path=ppt/notesSlides/notesSlide13.xml><?xml version="1.0" encoding="utf-8"?>
-<p:notes xmlns:a="http://schemas.openxmlformats.org/drawingml/2006/main" xmlns:r="http://schemas.openxmlformats.org/officeDocument/2006/relationships" xmlns:p="http://schemas.openxmlformats.org/presentationml/2006/main">
-  <p:cSld>
-    <p:spTree>
-      <p:nvGrpSpPr>
-        <p:cNvPr id="1" name=""/>
-        <p:cNvGrpSpPr/>
-        <p:nvPr/>
-      </p:nvGrpSpPr>
-      <p:grpSpPr>
-        <a:xfrm>
-          <a:off x="0" y="0"/>
-          <a:ext cx="0" cy="0"/>
-          <a:chOff x="0" y="0"/>
-          <a:chExt cx="0" cy="0"/>
-        </a:xfrm>
-      </p:grpSpPr>
-      <p:sp>
-        <p:nvSpPr>
-          <p:cNvPr id="2" name="Slide Image Placeholder 1"/>
-          <p:cNvSpPr>
-            <a:spLocks noGrp="1" noRot="1" noChangeAspect="1"/>
-          </p:cNvSpPr>
-          <p:nvPr>
-            <p:ph type="sldImg"/>
-          </p:nvPr>
-        </p:nvSpPr>
-        <p:spPr/>
-      </p:sp>
-      <p:sp>
-        <p:nvSpPr>
-          <p:cNvPr id="3" name="Notes Placeholder 2"/>
-          <p:cNvSpPr>
-            <a:spLocks noGrp="1"/>
-          </p:cNvSpPr>
-          <p:nvPr>
-            <p:ph type="body" idx="1"/>
-          </p:nvPr>
-        </p:nvSpPr>
-        <p:spPr/>
-        <p:txBody>
-          <a:bodyPr/>
-          <a:lstStyle/>
-          <a:p>
-            <a:r>
-              <a:rPr lang="en-US" dirty="0"/>
-              <a:t>TIME 0:44-0:52
-FACILITATOR: Use the signed-in account, list environments, and select the workshop target. RAPP imports live first and demo second because Dataverse handles one solution import at a time.
-DEFAULT: Leave Publish unchecked for a review-first workshop. After import, open the target environment in Copilot Studio. If live flows show pending connections, bind connection references and activate the flows; the demo twin remains available meanwhile.</a:t>
-            </a:r>
-            <a:endParaRPr lang="en-US" dirty="0"/>
-          </a:p>
-        </p:txBody>
-      </p:sp>
-      <p:sp>
-        <p:nvSpPr>
-          <p:cNvPr id="4" name="Slide Number Placeholder 3"/>
-          <p:cNvSpPr>
-            <a:spLocks noGrp="1"/>
-          </p:cNvSpPr>
-          <p:nvPr>
-            <p:ph type="sldNum" sz="quarter" idx="10"/>
-          </p:nvPr>
-        </p:nvSpPr>
-        <p:spPr/>
-        <p:txBody>
-          <a:bodyPr/>
-          <a:lstStyle/>
-          <a:p>
-            <a:fld id="{F7021451-1387-4CA6-816F-3879F97B5CBC}" type="slidenum">
-              <a:rPr lang="en-US"/>
-              <a:t>13</a:t>
-            </a:fld>
-            <a:endParaRPr lang="en-US"/>
-          </a:p>
-        </p:txBody>
-      </p:sp>
-    </p:spTree>
-    <p:extLst>
-      <p:ext uri="{BB962C8B-B14F-4D97-AF65-F5344CB8AC3E}">
-        <p14:creationId xmlns:p14="http://schemas.microsoft.com/office/powerpoint/2010/main" val="1024086991"/>
-      </p:ext>
-    </p:extLst>
-  </p:cSld>
-  <p:clrMapOvr>
-    <a:masterClrMapping/>
-  </p:clrMapOvr>
-</p:notes>
-</file>
-
-<file path=ppt/notesSlides/notesSlide14.xml><?xml version="1.0" encoding="utf-8"?>
-<p:notes xmlns:a="http://schemas.openxmlformats.org/drawingml/2006/main" xmlns:r="http://schemas.openxmlformats.org/officeDocument/2006/relationships" xmlns:p="http://schemas.openxmlformats.org/presentationml/2006/main">
-  <p:cSld>
-    <p:spTree>
-      <p:nvGrpSpPr>
-        <p:cNvPr id="1" name=""/>
-        <p:cNvGrpSpPr/>
-        <p:nvPr/>
-      </p:nvGrpSpPr>
-      <p:grpSpPr>
-        <a:xfrm>
-          <a:off x="0" y="0"/>
-          <a:ext cx="0" cy="0"/>
-          <a:chOff x="0" y="0"/>
-          <a:chExt cx="0" cy="0"/>
-        </a:xfrm>
-      </p:grpSpPr>
-      <p:sp>
-        <p:nvSpPr>
-          <p:cNvPr id="2" name="Slide Image Placeholder 1"/>
-          <p:cNvSpPr>
-            <a:spLocks noGrp="1" noRot="1" noChangeAspect="1"/>
-          </p:cNvSpPr>
-          <p:nvPr>
-            <p:ph type="sldImg"/>
-          </p:nvPr>
-        </p:nvSpPr>
-        <p:spPr/>
-      </p:sp>
-      <p:sp>
-        <p:nvSpPr>
-          <p:cNvPr id="3" name="Notes Placeholder 2"/>
-          <p:cNvSpPr>
-            <a:spLocks noGrp="1"/>
-          </p:cNvSpPr>
-          <p:nvPr>
-            <p:ph type="body" idx="1"/>
-          </p:nvPr>
-        </p:nvSpPr>
-        <p:spPr/>
-        <p:txBody>
-          <a:bodyPr/>
-          <a:lstStyle/>
-          <a:p>
-            <a:r>
-              <a:rPr lang="en-US" dirty="0"/>
-              <a:t>TIME 0:52-0:56
-FACILITATOR: Test one happy path, one edge case, and one unknown value. Score the agent against the confirmed MVP, not against every future idea.
-REFINE: If behavior is wrong, fix the source evidence or MVP statement, regenerate, and retest. Capture observations and a pass, fail, or mixed verdict if debug telemetry is enabled.</a:t>
-            </a:r>
-            <a:endParaRPr lang="en-US" dirty="0"/>
-          </a:p>
-        </p:txBody>
-      </p:sp>
-      <p:sp>
-        <p:nvSpPr>
-          <p:cNvPr id="4" name="Slide Number Placeholder 3"/>
-          <p:cNvSpPr>
-            <a:spLocks noGrp="1"/>
-          </p:cNvSpPr>
-          <p:nvPr>
-            <p:ph type="sldNum" sz="quarter" idx="10"/>
-          </p:nvPr>
-        </p:nvSpPr>
-        <p:spPr/>
-        <p:txBody>
-          <a:bodyPr/>
-          <a:lstStyle/>
-          <a:p>
-            <a:fld id="{F7021451-1387-4CA6-816F-3879F97B5CBC}" type="slidenum">
-              <a:rPr lang="en-US"/>
-              <a:t>14</a:t>
-            </a:fld>
-            <a:endParaRPr lang="en-US"/>
-          </a:p>
-        </p:txBody>
-      </p:sp>
-    </p:spTree>
-    <p:extLst>
-      <p:ext uri="{BB962C8B-B14F-4D97-AF65-F5344CB8AC3E}">
-        <p14:creationId xmlns:p14="http://schemas.microsoft.com/office/powerpoint/2010/main" val="1024086991"/>
-      </p:ext>
-    </p:extLst>
-  </p:cSld>
-  <p:clrMapOvr>
-    <a:masterClrMapping/>
-  </p:clrMapOvr>
-</p:notes>
-</file>
-
-<file path=ppt/notesSlides/notesSlide15.xml><?xml version="1.0" encoding="utf-8"?>
-<p:notes xmlns:a="http://schemas.openxmlformats.org/drawingml/2006/main" xmlns:r="http://schemas.openxmlformats.org/officeDocument/2006/relationships" xmlns:p="http://schemas.openxmlformats.org/presentationml/2006/main">
-  <p:cSld>
-    <p:spTree>
-      <p:nvGrpSpPr>
-        <p:cNvPr id="1" name=""/>
-        <p:cNvGrpSpPr/>
-        <p:nvPr/>
-      </p:nvGrpSpPr>
-      <p:grpSpPr>
-        <a:xfrm>
-          <a:off x="0" y="0"/>
-          <a:ext cx="0" cy="0"/>
-          <a:chOff x="0" y="0"/>
-          <a:chExt cx="0" cy="0"/>
-        </a:xfrm>
-      </p:grpSpPr>
-      <p:sp>
-        <p:nvSpPr>
-          <p:cNvPr id="2" name="Slide Image Placeholder 1"/>
-          <p:cNvSpPr>
-            <a:spLocks noGrp="1" noRot="1" noChangeAspect="1"/>
-          </p:cNvSpPr>
-          <p:nvPr>
-            <p:ph type="sldImg"/>
-          </p:nvPr>
-        </p:nvSpPr>
-        <p:spPr/>
-      </p:sp>
-      <p:sp>
-        <p:nvSpPr>
-          <p:cNvPr id="3" name="Notes Placeholder 2"/>
-          <p:cNvSpPr>
-            <a:spLocks noGrp="1"/>
-          </p:cNvSpPr>
-          <p:nvPr>
-            <p:ph type="body" idx="1"/>
-          </p:nvPr>
-        </p:nvSpPr>
-        <p:spPr/>
-        <p:txBody>
-          <a:bodyPr/>
-          <a:lstStyle/>
-          <a:p>
-            <a:r>
-              <a:rPr lang="en-US" dirty="0"/>
-              <a:t>TIME 0:56-0:58
-FACILITATOR: Reinforce the three gates. RAPP accelerates prototyping; it does not remove responsibility for data permission, factual review, security, connection governance, or publication approval.
-SAY: A fast prototype is valuable because it creates evidence sooner - not because it skips governance.</a:t>
-            </a:r>
-            <a:endParaRPr lang="en-US" dirty="0"/>
-          </a:p>
-        </p:txBody>
-      </p:sp>
-      <p:sp>
-        <p:nvSpPr>
-          <p:cNvPr id="4" name="Slide Number Placeholder 3"/>
-          <p:cNvSpPr>
-            <a:spLocks noGrp="1"/>
-          </p:cNvSpPr>
-          <p:nvPr>
-            <p:ph type="sldNum" sz="quarter" idx="10"/>
-          </p:nvPr>
-        </p:nvSpPr>
-        <p:spPr/>
-        <p:txBody>
-          <a:bodyPr/>
-          <a:lstStyle/>
-          <a:p>
-            <a:fld id="{F7021451-1387-4CA6-816F-3879F97B5CBC}" type="slidenum">
-              <a:rPr lang="en-US"/>
-              <a:t>15</a:t>
-            </a:fld>
-            <a:endParaRPr lang="en-US"/>
-          </a:p>
-        </p:txBody>
-      </p:sp>
-    </p:spTree>
-    <p:extLst>
-      <p:ext uri="{BB962C8B-B14F-4D97-AF65-F5344CB8AC3E}">
-        <p14:creationId xmlns:p14="http://schemas.microsoft.com/office/powerpoint/2010/main" val="1024086991"/>
-      </p:ext>
-    </p:extLst>
-  </p:cSld>
-  <p:clrMapOvr>
-    <a:masterClrMapping/>
-  </p:clrMapOvr>
-</p:notes>
-</file>
-
-<file path=ppt/notesSlides/notesSlide16.xml><?xml version="1.0" encoding="utf-8"?>
-<p:notes xmlns:a="http://schemas.openxmlformats.org/drawingml/2006/main" xmlns:r="http://schemas.openxmlformats.org/officeDocument/2006/relationships" xmlns:p="http://schemas.openxmlformats.org/presentationml/2006/main">
-  <p:cSld>
-    <p:spTree>
-      <p:nvGrpSpPr>
-        <p:cNvPr id="1" name=""/>
-        <p:cNvGrpSpPr/>
-        <p:nvPr/>
-      </p:nvGrpSpPr>
-      <p:grpSpPr>
-        <a:xfrm>
-          <a:off x="0" y="0"/>
-          <a:ext cx="0" cy="0"/>
-          <a:chOff x="0" y="0"/>
-          <a:chExt cx="0" cy="0"/>
-        </a:xfrm>
-      </p:grpSpPr>
-      <p:sp>
-        <p:nvSpPr>
-          <p:cNvPr id="2" name="Slide Image Placeholder 1"/>
-          <p:cNvSpPr>
-            <a:spLocks noGrp="1" noRot="1" noChangeAspect="1"/>
-          </p:cNvSpPr>
-          <p:nvPr>
-            <p:ph type="sldImg"/>
-          </p:nvPr>
-        </p:nvSpPr>
-        <p:spPr/>
-      </p:sp>
-      <p:sp>
-        <p:nvSpPr>
-          <p:cNvPr id="3" name="Notes Placeholder 2"/>
-          <p:cNvSpPr>
-            <a:spLocks noGrp="1"/>
-          </p:cNvSpPr>
-          <p:nvPr>
-            <p:ph type="body" idx="1"/>
-          </p:nvPr>
-        </p:nvSpPr>
-        <p:spPr/>
-        <p:txBody>
-          <a:bodyPr/>
-          <a:lstStyle/>
-          <a:p>
-            <a:r>
-              <a:rPr lang="en-US" dirty="0"/>
-              <a:t>TIME 0:58-1:00
-FACILITATOR: Pair participants. Each person gets 90 seconds: name the five steps, show one artifact, and name the next change. Close by checking the definition of done.
-CAPTURE: Ask for one sentence of feedback: What made the process feel fast, and where did confidence drop?</a:t>
-            </a:r>
-            <a:endParaRPr lang="en-US" dirty="0"/>
-          </a:p>
-        </p:txBody>
-      </p:sp>
-      <p:sp>
-        <p:nvSpPr>
-          <p:cNvPr id="4" name="Slide Number Placeholder 3"/>
-          <p:cNvSpPr>
-            <a:spLocks noGrp="1"/>
-          </p:cNvSpPr>
-          <p:nvPr>
-            <p:ph type="sldNum" sz="quarter" idx="10"/>
-          </p:nvPr>
-        </p:nvSpPr>
-        <p:spPr/>
-        <p:txBody>
-          <a:bodyPr/>
-          <a:lstStyle/>
-          <a:p>
-            <a:fld id="{F7021451-1387-4CA6-816F-3879F97B5CBC}" type="slidenum">
-              <a:rPr lang="en-US"/>
-              <a:t>16</a:t>
-            </a:fld>
-            <a:endParaRPr lang="en-US"/>
-          </a:p>
-        </p:txBody>
-      </p:sp>
-    </p:spTree>
-    <p:extLst>
-      <p:ext uri="{BB962C8B-B14F-4D97-AF65-F5344CB8AC3E}">
-        <p14:creationId xmlns:p14="http://schemas.microsoft.com/office/powerpoint/2010/main" val="1024086991"/>
-      </p:ext>
-    </p:extLst>
-  </p:cSld>
-  <p:clrMapOvr>
-    <a:masterClrMapping/>
-  </p:clrMapOvr>
-</p:notes>
-</file>
-
-<file path=ppt/notesSlides/notesSlide17.xml><?xml version="1.0" encoding="utf-8"?>
-<p:notes xmlns:a="http://schemas.openxmlformats.org/drawingml/2006/main" xmlns:r="http://schemas.openxmlformats.org/officeDocument/2006/relationships" xmlns:p="http://schemas.openxmlformats.org/presentationml/2006/main">
-  <p:cSld>
-    <p:spTree>
-      <p:nvGrpSpPr>
-        <p:cNvPr id="1" name=""/>
-        <p:cNvGrpSpPr/>
-        <p:nvPr/>
-      </p:nvGrpSpPr>
-      <p:grpSpPr>
-        <a:xfrm>
-          <a:off x="0" y="0"/>
-          <a:ext cx="0" cy="0"/>
-          <a:chOff x="0" y="0"/>
-          <a:chExt cx="0" cy="0"/>
-        </a:xfrm>
-      </p:grpSpPr>
-      <p:sp>
-        <p:nvSpPr>
-          <p:cNvPr id="2" name="Slide Image Placeholder 1"/>
-          <p:cNvSpPr>
-            <a:spLocks noGrp="1" noRot="1" noChangeAspect="1"/>
-          </p:cNvSpPr>
-          <p:nvPr>
-            <p:ph type="sldImg"/>
-          </p:nvPr>
-        </p:nvSpPr>
-        <p:spPr/>
-      </p:sp>
-      <p:sp>
-        <p:nvSpPr>
-          <p:cNvPr id="3" name="Notes Placeholder 2"/>
-          <p:cNvSpPr>
-            <a:spLocks noGrp="1"/>
-          </p:cNvSpPr>
-          <p:nvPr>
-            <p:ph type="body" idx="1"/>
-          </p:nvPr>
-        </p:nvSpPr>
-        <p:spPr/>
-        <p:txBody>
-          <a:bodyPr/>
-          <a:lstStyle/>
-          <a:p>
-            <a:r>
-              <a:rPr lang="en-US" dirty="0"/>
-              <a:t>CLOSE: Thank the room. Remind participants that the workshop output is a prototype and evidence package, not an automatic production approval. Point facilitators to the appendix for the BOM, pre-survey, pilot handoffs, troubleshooting, and quick reference.</a:t>
-            </a:r>
-            <a:endParaRPr lang="en-US" dirty="0"/>
-          </a:p>
-        </p:txBody>
-      </p:sp>
-      <p:sp>
-        <p:nvSpPr>
-          <p:cNvPr id="4" name="Slide Number Placeholder 3"/>
-          <p:cNvSpPr>
-            <a:spLocks noGrp="1"/>
-          </p:cNvSpPr>
-          <p:nvPr>
-            <p:ph type="sldNum" sz="quarter" idx="10"/>
-          </p:nvPr>
-        </p:nvSpPr>
-        <p:spPr/>
-        <p:txBody>
-          <a:bodyPr/>
-          <a:lstStyle/>
-          <a:p>
-            <a:fld id="{F7021451-1387-4CA6-816F-3879F97B5CBC}" type="slidenum">
-              <a:rPr lang="en-US"/>
-              <a:t>17</a:t>
-            </a:fld>
-            <a:endParaRPr lang="en-US"/>
-          </a:p>
-        </p:txBody>
-      </p:sp>
-    </p:spTree>
-    <p:extLst>
-      <p:ext uri="{BB962C8B-B14F-4D97-AF65-F5344CB8AC3E}">
-        <p14:creationId xmlns:p14="http://schemas.microsoft.com/office/powerpoint/2010/main" val="1024086991"/>
-      </p:ext>
-    </p:extLst>
-  </p:cSld>
-  <p:clrMapOvr>
-    <a:masterClrMapping/>
-  </p:clrMapOvr>
-</p:notes>
-</file>
-
-<file path=ppt/notesSlides/notesSlide18.xml><?xml version="1.0" encoding="utf-8"?>
-<p:notes xmlns:a="http://schemas.openxmlformats.org/drawingml/2006/main" xmlns:r="http://schemas.openxmlformats.org/officeDocument/2006/relationships" xmlns:p="http://schemas.openxmlformats.org/presentationml/2006/main">
-  <p:cSld>
-    <p:spTree>
-      <p:nvGrpSpPr>
-        <p:cNvPr id="1" name=""/>
-        <p:cNvGrpSpPr/>
-        <p:nvPr/>
-      </p:nvGrpSpPr>
-      <p:grpSpPr>
-        <a:xfrm>
-          <a:off x="0" y="0"/>
-          <a:ext cx="0" cy="0"/>
-          <a:chOff x="0" y="0"/>
-          <a:chExt cx="0" cy="0"/>
-        </a:xfrm>
-      </p:grpSpPr>
-      <p:sp>
-        <p:nvSpPr>
-          <p:cNvPr id="2" name="Slide Image Placeholder 1"/>
-          <p:cNvSpPr>
-            <a:spLocks noGrp="1" noRot="1" noChangeAspect="1"/>
-          </p:cNvSpPr>
-          <p:nvPr>
-            <p:ph type="sldImg"/>
-          </p:nvPr>
-        </p:nvSpPr>
-        <p:spPr/>
-      </p:sp>
-      <p:sp>
-        <p:nvSpPr>
-          <p:cNvPr id="3" name="Notes Placeholder 2"/>
-          <p:cNvSpPr>
-            <a:spLocks noGrp="1"/>
-          </p:cNvSpPr>
-          <p:nvPr>
-            <p:ph type="body" idx="1"/>
-          </p:nvPr>
-        </p:nvSpPr>
-        <p:spPr/>
-        <p:txBody>
-          <a:bodyPr/>
-          <a:lstStyle/>
-          <a:p>
-            <a:r>
-              <a:rPr lang="en-US" dirty="0"/>
-              <a:t>FACILITATOR PREP: Run the exact scenario end to end before the session. Confirm account access, environment discovery, generation, import, Copilot Studio test, and fallback artifacts. Keep a clean demo twin ZIP ready so the workshop can continue during a service or permission issue.</a:t>
-            </a:r>
-            <a:endParaRPr lang="en-US" dirty="0"/>
-          </a:p>
-        </p:txBody>
-      </p:sp>
-      <p:sp>
-        <p:nvSpPr>
-          <p:cNvPr id="4" name="Slide Number Placeholder 3"/>
-          <p:cNvSpPr>
-            <a:spLocks noGrp="1"/>
-          </p:cNvSpPr>
-          <p:nvPr>
-            <p:ph type="sldNum" sz="quarter" idx="10"/>
-          </p:nvPr>
-        </p:nvSpPr>
-        <p:spPr/>
-        <p:txBody>
-          <a:bodyPr/>
-          <a:lstStyle/>
-          <a:p>
-            <a:fld id="{F7021451-1387-4CA6-816F-3879F97B5CBC}" type="slidenum">
-              <a:rPr lang="en-US"/>
-              <a:t>18</a:t>
-            </a:fld>
-            <a:endParaRPr lang="en-US"/>
-          </a:p>
-        </p:txBody>
-      </p:sp>
-    </p:spTree>
-    <p:extLst>
-      <p:ext uri="{BB962C8B-B14F-4D97-AF65-F5344CB8AC3E}">
-        <p14:creationId xmlns:p14="http://schemas.microsoft.com/office/powerpoint/2010/main" val="1024086991"/>
-      </p:ext>
-    </p:extLst>
-  </p:cSld>
-  <p:clrMapOvr>
-    <a:masterClrMapping/>
-  </p:clrMapOvr>
-</p:notes>
-</file>
-
-<file path=ppt/notesSlides/notesSlide19.xml><?xml version="1.0" encoding="utf-8"?>
-<p:notes xmlns:a="http://schemas.openxmlformats.org/drawingml/2006/main" xmlns:r="http://schemas.openxmlformats.org/officeDocument/2006/relationships" xmlns:p="http://schemas.openxmlformats.org/presentationml/2006/main">
-  <p:cSld>
-    <p:spTree>
-      <p:nvGrpSpPr>
-        <p:cNvPr id="1" name=""/>
-        <p:cNvGrpSpPr/>
-        <p:nvPr/>
-      </p:nvGrpSpPr>
-      <p:grpSpPr>
-        <a:xfrm>
-          <a:off x="0" y="0"/>
-          <a:ext cx="0" cy="0"/>
-          <a:chOff x="0" y="0"/>
-          <a:chExt cx="0" cy="0"/>
-        </a:xfrm>
-      </p:grpSpPr>
-      <p:sp>
-        <p:nvSpPr>
-          <p:cNvPr id="2" name="Slide Image Placeholder 1"/>
-          <p:cNvSpPr>
-            <a:spLocks noGrp="1" noRot="1" noChangeAspect="1"/>
-          </p:cNvSpPr>
-          <p:nvPr>
-            <p:ph type="sldImg"/>
-          </p:nvPr>
-        </p:nvSpPr>
-        <p:spPr/>
-      </p:sp>
-      <p:sp>
-        <p:nvSpPr>
-          <p:cNvPr id="3" name="Notes Placeholder 2"/>
-          <p:cNvSpPr>
-            <a:spLocks noGrp="1"/>
-          </p:cNvSpPr>
-          <p:nvPr>
-            <p:ph type="body" idx="1"/>
-          </p:nvPr>
-        </p:nvSpPr>
-        <p:spPr/>
-        <p:txBody>
-          <a:bodyPr/>
-          <a:lstStyle/>
-          <a:p>
-            <a:r>
-              <a:rPr lang="en-US" dirty="0"/>
-              <a:t>COPY/PASTE SURVEY:
-1. What business problem should the agent solve?
-2. Who uses the process today?
-3. What happens from trigger to outcome?
-4. What are the top one to three capabilities?
-5. Which systems or approved knowledge are involved?
-6. What sanitized sample file can you safely provide, and what is its data classification?
-7. What one measurable signal means the prototype worked?
-8. Will attendees have Copilot Studio maker access to the target environment?
-Use responses to select one scenario; do not turn the survey into a second discovery workshop.</a:t>
-            </a:r>
-            <a:endParaRPr lang="en-US" dirty="0"/>
-          </a:p>
-        </p:txBody>
-      </p:sp>
-      <p:sp>
-        <p:nvSpPr>
-          <p:cNvPr id="4" name="Slide Number Placeholder 3"/>
-          <p:cNvSpPr>
-            <a:spLocks noGrp="1"/>
-          </p:cNvSpPr>
-          <p:nvPr>
-            <p:ph type="sldNum" sz="quarter" idx="10"/>
-          </p:nvPr>
-        </p:nvSpPr>
-        <p:spPr/>
-        <p:txBody>
-          <a:bodyPr/>
-          <a:lstStyle/>
-          <a:p>
-            <a:fld id="{F7021451-1387-4CA6-816F-3879F97B5CBC}" type="slidenum">
-              <a:rPr lang="en-US"/>
-              <a:t>19</a:t>
-            </a:fld>
-            <a:endParaRPr lang="en-US"/>
-          </a:p>
-        </p:txBody>
-      </p:sp>
-    </p:spTree>
-    <p:extLst>
-      <p:ext uri="{BB962C8B-B14F-4D97-AF65-F5344CB8AC3E}">
-        <p14:creationId xmlns:p14="http://schemas.microsoft.com/office/powerpoint/2010/main" val="1024086991"/>
-      </p:ext>
-    </p:extLst>
-  </p:cSld>
-  <p:clrMapOvr>
-    <a:masterClrMapping/>
-  </p:clrMapOvr>
-</p:notes>
-</file>
-
-<file path=ppt/notesSlides/notesSlide2.xml><?xml version="1.0" encoding="utf-8"?>
-<p:notes xmlns:a="http://schemas.openxmlformats.org/drawingml/2006/main" xmlns:r="http://schemas.openxmlformats.org/officeDocument/2006/relationships" xmlns:p="http://schemas.openxmlformats.org/presentationml/2006/main">
-  <p:cSld>
-    <p:spTree>
-      <p:nvGrpSpPr>
-        <p:cNvPr id="1" name=""/>
-        <p:cNvGrpSpPr/>
-        <p:nvPr/>
-      </p:nvGrpSpPr>
-      <p:grpSpPr>
-        <a:xfrm>
-          <a:off x="0" y="0"/>
-          <a:ext cx="0" cy="0"/>
-          <a:chOff x="0" y="0"/>
-          <a:chExt cx="0" cy="0"/>
-        </a:xfrm>
-      </p:grpSpPr>
-      <p:sp>
-        <p:nvSpPr>
-          <p:cNvPr id="2" name="Slide Image Placeholder 1"/>
-          <p:cNvSpPr>
-            <a:spLocks noGrp="1" noRot="1" noChangeAspect="1"/>
-          </p:cNvSpPr>
-          <p:nvPr>
-            <p:ph type="sldImg"/>
-          </p:nvPr>
-        </p:nvSpPr>
-        <p:spPr/>
-      </p:sp>
-      <p:sp>
-        <p:nvSpPr>
-          <p:cNvPr id="3" name="Notes Placeholder 2"/>
-          <p:cNvSpPr>
-            <a:spLocks noGrp="1"/>
-          </p:cNvSpPr>
-          <p:nvPr>
-            <p:ph type="body" idx="1"/>
-          </p:nvPr>
-        </p:nvSpPr>
-        <p:spPr/>
-        <p:txBody>
-          <a:bodyPr/>
-          <a:lstStyle/>
-          <a:p>
-            <a:r>
-              <a:rPr lang="en-US" dirty="0"/>
-              <a:t>TIME 0:01-0:02
-FACILITATOR: Read the four outcomes. Ask participants to keep one source document and one target environment in mind.
-SUCCESS: Every participant can name the input, the two generated solution twins, and the target deployment environment.</a:t>
-            </a:r>
-            <a:endParaRPr lang="en-US" dirty="0"/>
-          </a:p>
-        </p:txBody>
-      </p:sp>
-      <p:sp>
-        <p:nvSpPr>
-          <p:cNvPr id="4" name="Slide Number Placeholder 3"/>
-          <p:cNvSpPr>
-            <a:spLocks noGrp="1"/>
-          </p:cNvSpPr>
-          <p:nvPr>
-            <p:ph type="sldNum" sz="quarter" idx="10"/>
-          </p:nvPr>
-        </p:nvSpPr>
-        <p:spPr/>
-        <p:txBody>
-          <a:bodyPr/>
-          <a:lstStyle/>
-          <a:p>
-            <a:fld id="{F7021451-1387-4CA6-816F-3879F97B5CBC}" type="slidenum">
-              <a:rPr lang="en-US"/>
-              <a:t>2</a:t>
-            </a:fld>
-            <a:endParaRPr lang="en-US"/>
-          </a:p>
-        </p:txBody>
-      </p:sp>
-    </p:spTree>
-    <p:extLst>
-      <p:ext uri="{BB962C8B-B14F-4D97-AF65-F5344CB8AC3E}">
-        <p14:creationId xmlns:p14="http://schemas.microsoft.com/office/powerpoint/2010/main" val="1024086991"/>
-      </p:ext>
-    </p:extLst>
-  </p:cSld>
-  <p:clrMapOvr>
-    <a:masterClrMapping/>
-  </p:clrMapOvr>
-</p:notes>
-</file>
-
-<file path=ppt/notesSlides/notesSlide20.xml><?xml version="1.0" encoding="utf-8"?>
-<p:notes xmlns:a="http://schemas.openxmlformats.org/drawingml/2006/main" xmlns:r="http://schemas.openxmlformats.org/officeDocument/2006/relationships" xmlns:p="http://schemas.openxmlformats.org/presentationml/2006/main">
-  <p:cSld>
-    <p:spTree>
-      <p:nvGrpSpPr>
-        <p:cNvPr id="1" name=""/>
-        <p:cNvGrpSpPr/>
-        <p:nvPr/>
-      </p:nvGrpSpPr>
-      <p:grpSpPr>
-        <a:xfrm>
-          <a:off x="0" y="0"/>
-          <a:ext cx="0" cy="0"/>
-          <a:chOff x="0" y="0"/>
-          <a:chExt cx="0" cy="0"/>
-        </a:xfrm>
-      </p:grpSpPr>
-      <p:sp>
-        <p:nvSpPr>
-          <p:cNvPr id="2" name="Slide Image Placeholder 1"/>
-          <p:cNvSpPr>
-            <a:spLocks noGrp="1" noRot="1" noChangeAspect="1"/>
-          </p:cNvSpPr>
-          <p:nvPr>
-            <p:ph type="sldImg"/>
-          </p:nvPr>
-        </p:nvSpPr>
-        <p:spPr/>
-      </p:sp>
-      <p:sp>
-        <p:nvSpPr>
-          <p:cNvPr id="3" name="Notes Placeholder 2"/>
-          <p:cNvSpPr>
-            <a:spLocks noGrp="1"/>
-          </p:cNvSpPr>
-          <p:nvPr>
-            <p:ph type="body" idx="1"/>
-          </p:nvPr>
-        </p:nvSpPr>
-        <p:spPr/>
-        <p:txBody>
-          <a:bodyPr/>
-          <a:lstStyle/>
-          <a:p>
-            <a:r>
-              <a:rPr lang="en-US" dirty="0"/>
-              <a:t>PILOT COORDINATION: Treat this as a proposed division of labor and confirm it with pilot leadership. Share a distilled RAPP module so partners do not repeat the mechanics of source upload, MVP confirmation, generation, deployment, or test. RAPP should consume the confirmed scenario produced by discovery, then hand prototype evidence to delivery planning.</a:t>
-            </a:r>
-            <a:endParaRPr lang="en-US" dirty="0"/>
-          </a:p>
-        </p:txBody>
-      </p:sp>
-      <p:sp>
-        <p:nvSpPr>
-          <p:cNvPr id="4" name="Slide Number Placeholder 3"/>
-          <p:cNvSpPr>
-            <a:spLocks noGrp="1"/>
-          </p:cNvSpPr>
-          <p:nvPr>
-            <p:ph type="sldNum" sz="quarter" idx="10"/>
-          </p:nvPr>
-        </p:nvSpPr>
-        <p:spPr/>
-        <p:txBody>
-          <a:bodyPr/>
-          <a:lstStyle/>
-          <a:p>
-            <a:fld id="{F7021451-1387-4CA6-816F-3879F97B5CBC}" type="slidenum">
-              <a:rPr lang="en-US"/>
-              <a:t>20</a:t>
-            </a:fld>
-            <a:endParaRPr lang="en-US"/>
-          </a:p>
-        </p:txBody>
-      </p:sp>
-    </p:spTree>
-    <p:extLst>
-      <p:ext uri="{BB962C8B-B14F-4D97-AF65-F5344CB8AC3E}">
-        <p14:creationId xmlns:p14="http://schemas.microsoft.com/office/powerpoint/2010/main" val="1024086991"/>
-      </p:ext>
-    </p:extLst>
-  </p:cSld>
-  <p:clrMapOvr>
-    <a:masterClrMapping/>
-  </p:clrMapOvr>
-</p:notes>
-</file>
-
-<file path=ppt/notesSlides/notesSlide21.xml><?xml version="1.0" encoding="utf-8"?>
-<p:notes xmlns:a="http://schemas.openxmlformats.org/drawingml/2006/main" xmlns:r="http://schemas.openxmlformats.org/officeDocument/2006/relationships" xmlns:p="http://schemas.openxmlformats.org/presentationml/2006/main">
-  <p:cSld>
-    <p:spTree>
-      <p:nvGrpSpPr>
-        <p:cNvPr id="1" name=""/>
-        <p:cNvGrpSpPr/>
-        <p:nvPr/>
-      </p:nvGrpSpPr>
-      <p:grpSpPr>
-        <a:xfrm>
-          <a:off x="0" y="0"/>
-          <a:ext cx="0" cy="0"/>
-          <a:chOff x="0" y="0"/>
-          <a:chExt cx="0" cy="0"/>
-        </a:xfrm>
-      </p:grpSpPr>
-      <p:sp>
-        <p:nvSpPr>
-          <p:cNvPr id="2" name="Slide Image Placeholder 1"/>
-          <p:cNvSpPr>
-            <a:spLocks noGrp="1" noRot="1" noChangeAspect="1"/>
-          </p:cNvSpPr>
-          <p:nvPr>
-            <p:ph type="sldImg"/>
-          </p:nvPr>
-        </p:nvSpPr>
-        <p:spPr/>
-      </p:sp>
-      <p:sp>
-        <p:nvSpPr>
-          <p:cNvPr id="3" name="Notes Placeholder 2"/>
-          <p:cNvSpPr>
-            <a:spLocks noGrp="1"/>
-          </p:cNvSpPr>
-          <p:nvPr>
-            <p:ph type="body" idx="1"/>
-          </p:nvPr>
-        </p:nvSpPr>
-        <p:spPr/>
-        <p:txBody>
-          <a:bodyPr/>
-          <a:lstStyle/>
-          <a:p>
-            <a:r>
-              <a:rPr lang="en-US" dirty="0"/>
-              <a:t>FACILITATOR: Use the three-minute rule. If a blocker cannot be fixed quickly, pair the participant or switch to the prebuilt demo twin. Keep debug telemetry enabled for runs that need diagnosis and export the self-contained test case after testing.</a:t>
-            </a:r>
-            <a:endParaRPr lang="en-US" dirty="0"/>
-          </a:p>
-        </p:txBody>
-      </p:sp>
-      <p:sp>
-        <p:nvSpPr>
-          <p:cNvPr id="4" name="Slide Number Placeholder 3"/>
-          <p:cNvSpPr>
-            <a:spLocks noGrp="1"/>
-          </p:cNvSpPr>
-          <p:nvPr>
-            <p:ph type="sldNum" sz="quarter" idx="10"/>
-          </p:nvPr>
-        </p:nvSpPr>
-        <p:spPr/>
-        <p:txBody>
-          <a:bodyPr/>
-          <a:lstStyle/>
-          <a:p>
-            <a:fld id="{F7021451-1387-4CA6-816F-3879F97B5CBC}" type="slidenum">
-              <a:rPr lang="en-US"/>
-              <a:t>21</a:t>
-            </a:fld>
-            <a:endParaRPr lang="en-US"/>
-          </a:p>
-        </p:txBody>
-      </p:sp>
-    </p:spTree>
-    <p:extLst>
-      <p:ext uri="{BB962C8B-B14F-4D97-AF65-F5344CB8AC3E}">
-        <p14:creationId xmlns:p14="http://schemas.microsoft.com/office/powerpoint/2010/main" val="1024086991"/>
-      </p:ext>
-    </p:extLst>
-  </p:cSld>
-  <p:clrMapOvr>
-    <a:masterClrMapping/>
-  </p:clrMapOvr>
-</p:notes>
-</file>
-
-<file path=ppt/notesSlides/notesSlide22.xml><?xml version="1.0" encoding="utf-8"?>
-<p:notes xmlns:a="http://schemas.openxmlformats.org/drawingml/2006/main" xmlns:r="http://schemas.openxmlformats.org/officeDocument/2006/relationships" xmlns:p="http://schemas.openxmlformats.org/presentationml/2006/main">
-  <p:cSld>
-    <p:spTree>
-      <p:nvGrpSpPr>
-        <p:cNvPr id="1" name=""/>
-        <p:cNvGrpSpPr/>
-        <p:nvPr/>
-      </p:nvGrpSpPr>
-      <p:grpSpPr>
-        <a:xfrm>
-          <a:off x="0" y="0"/>
-          <a:ext cx="0" cy="0"/>
-          <a:chOff x="0" y="0"/>
-          <a:chExt cx="0" cy="0"/>
-        </a:xfrm>
-      </p:grpSpPr>
-      <p:sp>
-        <p:nvSpPr>
-          <p:cNvPr id="2" name="Slide Image Placeholder 1"/>
-          <p:cNvSpPr>
-            <a:spLocks noGrp="1" noRot="1" noChangeAspect="1"/>
-          </p:cNvSpPr>
-          <p:nvPr>
-            <p:ph type="sldImg"/>
-          </p:nvPr>
-        </p:nvSpPr>
-        <p:spPr/>
-      </p:sp>
-      <p:sp>
-        <p:nvSpPr>
-          <p:cNvPr id="3" name="Notes Placeholder 2"/>
-          <p:cNvSpPr>
-            <a:spLocks noGrp="1"/>
-          </p:cNvSpPr>
-          <p:nvPr>
-            <p:ph type="body" idx="1"/>
-          </p:nvPr>
-        </p:nvSpPr>
-        <p:spPr/>
-        <p:txBody>
-          <a:bodyPr/>
-          <a:lstStyle/>
-          <a:p>
-            <a:r>
-              <a:rPr lang="en-US" dirty="0"/>
-              <a:t>PRINT OR EXPORT: This slide is the participant one-page reference. Pair it with the scenario source and the pre-session survey. The quality check is the minimum evidence expected from a completed workshop run.</a:t>
-            </a:r>
-            <a:endParaRPr lang="en-US" dirty="0"/>
-          </a:p>
-        </p:txBody>
-      </p:sp>
-      <p:sp>
-        <p:nvSpPr>
-          <p:cNvPr id="4" name="Slide Number Placeholder 3"/>
-          <p:cNvSpPr>
-            <a:spLocks noGrp="1"/>
-          </p:cNvSpPr>
-          <p:nvPr>
-            <p:ph type="sldNum" sz="quarter" idx="10"/>
-          </p:nvPr>
-        </p:nvSpPr>
-        <p:spPr/>
-        <p:txBody>
-          <a:bodyPr/>
-          <a:lstStyle/>
-          <a:p>
-            <a:fld id="{F7021451-1387-4CA6-816F-3879F97B5CBC}" type="slidenum">
-              <a:rPr lang="en-US"/>
-              <a:t>22</a:t>
-            </a:fld>
-            <a:endParaRPr lang="en-US"/>
-          </a:p>
-        </p:txBody>
-      </p:sp>
-    </p:spTree>
-    <p:extLst>
-      <p:ext uri="{BB962C8B-B14F-4D97-AF65-F5344CB8AC3E}">
-        <p14:creationId xmlns:p14="http://schemas.microsoft.com/office/powerpoint/2010/main" val="1024086991"/>
-      </p:ext>
-    </p:extLst>
-  </p:cSld>
-  <p:clrMapOvr>
-    <a:masterClrMapping/>
-  </p:clrMapOvr>
-</p:notes>
-</file>
-
-<file path=ppt/notesSlides/notesSlide3.xml><?xml version="1.0" encoding="utf-8"?>
-<p:notes xmlns:a="http://schemas.openxmlformats.org/drawingml/2006/main" xmlns:r="http://schemas.openxmlformats.org/officeDocument/2006/relationships" xmlns:p="http://schemas.openxmlformats.org/presentationml/2006/main">
-  <p:cSld>
-    <p:spTree>
-      <p:nvGrpSpPr>
-        <p:cNvPr id="1" name=""/>
-        <p:cNvGrpSpPr/>
-        <p:nvPr/>
-      </p:nvGrpSpPr>
-      <p:grpSpPr>
-        <a:xfrm>
-          <a:off x="0" y="0"/>
-          <a:ext cx="0" cy="0"/>
-          <a:chOff x="0" y="0"/>
-          <a:chExt cx="0" cy="0"/>
-        </a:xfrm>
-      </p:grpSpPr>
-      <p:sp>
-        <p:nvSpPr>
-          <p:cNvPr id="2" name="Slide Image Placeholder 1"/>
-          <p:cNvSpPr>
-            <a:spLocks noGrp="1" noRot="1" noChangeAspect="1"/>
-          </p:cNvSpPr>
-          <p:nvPr>
-            <p:ph type="sldImg"/>
-          </p:nvPr>
-        </p:nvSpPr>
-        <p:spPr/>
-      </p:sp>
-      <p:sp>
-        <p:nvSpPr>
-          <p:cNvPr id="3" name="Notes Placeholder 2"/>
-          <p:cNvSpPr>
-            <a:spLocks noGrp="1"/>
-          </p:cNvSpPr>
-          <p:nvPr>
-            <p:ph type="body" idx="1"/>
-          </p:nvPr>
-        </p:nvSpPr>
-        <p:spPr/>
-        <p:txBody>
-          <a:bodyPr/>
-          <a:lstStyle/>
-          <a:p>
-            <a:r>
-              <a:rPr lang="en-US" dirty="0"/>
-              <a:t>TIME 0:02-0:04
-FACILITATOR: Walk the timeline quickly. Protect the MVP, deploy, and test blocks; compress the opening explanation if the room is late.
-TIP: Pair participants so one drives while one reads the source and checks the generated result.</a:t>
-            </a:r>
-            <a:endParaRPr lang="en-US" dirty="0"/>
-          </a:p>
-        </p:txBody>
-      </p:sp>
-      <p:sp>
-        <p:nvSpPr>
-          <p:cNvPr id="4" name="Slide Number Placeholder 3"/>
-          <p:cNvSpPr>
-            <a:spLocks noGrp="1"/>
-          </p:cNvSpPr>
-          <p:nvPr>
-            <p:ph type="sldNum" sz="quarter" idx="10"/>
-          </p:nvPr>
-        </p:nvSpPr>
-        <p:spPr/>
-        <p:txBody>
-          <a:bodyPr/>
-          <a:lstStyle/>
-          <a:p>
-            <a:fld id="{F7021451-1387-4CA6-816F-3879F97B5CBC}" type="slidenum">
-              <a:rPr lang="en-US"/>
-              <a:t>3</a:t>
-            </a:fld>
-            <a:endParaRPr lang="en-US"/>
-          </a:p>
-        </p:txBody>
-      </p:sp>
-    </p:spTree>
-    <p:extLst>
-      <p:ext uri="{BB962C8B-B14F-4D97-AF65-F5344CB8AC3E}">
-        <p14:creationId xmlns:p14="http://schemas.microsoft.com/office/powerpoint/2010/main" val="1024086991"/>
-      </p:ext>
-    </p:extLst>
-  </p:cSld>
-  <p:clrMapOvr>
-    <a:masterClrMapping/>
-  </p:clrMapOvr>
-</p:notes>
-</file>
-
-<file path=ppt/notesSlides/notesSlide4.xml><?xml version="1.0" encoding="utf-8"?>
-<p:notes xmlns:a="http://schemas.openxmlformats.org/drawingml/2006/main" xmlns:r="http://schemas.openxmlformats.org/officeDocument/2006/relationships" xmlns:p="http://schemas.openxmlformats.org/presentationml/2006/main">
-  <p:cSld>
-    <p:spTree>
-      <p:nvGrpSpPr>
-        <p:cNvPr id="1" name=""/>
-        <p:cNvGrpSpPr/>
-        <p:nvPr/>
-      </p:nvGrpSpPr>
-      <p:grpSpPr>
-        <a:xfrm>
-          <a:off x="0" y="0"/>
-          <a:ext cx="0" cy="0"/>
-          <a:chOff x="0" y="0"/>
-          <a:chExt cx="0" cy="0"/>
-        </a:xfrm>
-      </p:grpSpPr>
-      <p:sp>
-        <p:nvSpPr>
-          <p:cNvPr id="2" name="Slide Image Placeholder 1"/>
-          <p:cNvSpPr>
-            <a:spLocks noGrp="1" noRot="1" noChangeAspect="1"/>
-          </p:cNvSpPr>
-          <p:nvPr>
-            <p:ph type="sldImg"/>
-          </p:nvPr>
-        </p:nvSpPr>
-        <p:spPr/>
-      </p:sp>
-      <p:sp>
-        <p:nvSpPr>
-          <p:cNvPr id="3" name="Notes Placeholder 2"/>
-          <p:cNvSpPr>
-            <a:spLocks noGrp="1"/>
-          </p:cNvSpPr>
-          <p:nvPr>
-            <p:ph type="body" idx="1"/>
-          </p:nvPr>
-        </p:nvSpPr>
-        <p:spPr/>
-        <p:txBody>
-          <a:bodyPr/>
-          <a:lstStyle/>
-          <a:p>
-            <a:r>
-              <a:rPr lang="en-US" dirty="0"/>
-              <a:t>TIME 0:04-0:07
-FACILITATOR: Position RAPP as an accelerator that feeds the Microsoft ecosystem. The broader platform can translate into multiple destinations; this hour intentionally narrows the path to Copilot Studio.
-SAY: We are preserving portability: agent logic and packages can be reviewed and shared instead of being trapped in a single chat.</a:t>
-            </a:r>
-            <a:endParaRPr lang="en-US" dirty="0"/>
-          </a:p>
-        </p:txBody>
-      </p:sp>
-      <p:sp>
-        <p:nvSpPr>
-          <p:cNvPr id="4" name="Slide Number Placeholder 3"/>
-          <p:cNvSpPr>
-            <a:spLocks noGrp="1"/>
-          </p:cNvSpPr>
-          <p:nvPr>
-            <p:ph type="sldNum" sz="quarter" idx="10"/>
-          </p:nvPr>
-        </p:nvSpPr>
-        <p:spPr/>
-        <p:txBody>
-          <a:bodyPr/>
-          <a:lstStyle/>
-          <a:p>
-            <a:fld id="{F7021451-1387-4CA6-816F-3879F97B5CBC}" type="slidenum">
-              <a:rPr lang="en-US"/>
-              <a:t>4</a:t>
-            </a:fld>
-            <a:endParaRPr lang="en-US"/>
-          </a:p>
-        </p:txBody>
-      </p:sp>
-    </p:spTree>
-    <p:extLst>
-      <p:ext uri="{BB962C8B-B14F-4D97-AF65-F5344CB8AC3E}">
-        <p14:creationId xmlns:p14="http://schemas.microsoft.com/office/powerpoint/2010/main" val="1024086991"/>
-      </p:ext>
-    </p:extLst>
-  </p:cSld>
-  <p:clrMapOvr>
-    <a:masterClrMapping/>
-  </p:clrMapOvr>
-</p:notes>
-</file>
-
-<file path=ppt/notesSlides/notesSlide5.xml><?xml version="1.0" encoding="utf-8"?>
-<p:notes xmlns:a="http://schemas.openxmlformats.org/drawingml/2006/main" xmlns:r="http://schemas.openxmlformats.org/officeDocument/2006/relationships" xmlns:p="http://schemas.openxmlformats.org/presentationml/2006/main">
-  <p:cSld>
-    <p:spTree>
-      <p:nvGrpSpPr>
-        <p:cNvPr id="1" name=""/>
-        <p:cNvGrpSpPr/>
-        <p:nvPr/>
-      </p:nvGrpSpPr>
-      <p:grpSpPr>
-        <a:xfrm>
-          <a:off x="0" y="0"/>
-          <a:ext cx="0" cy="0"/>
-          <a:chOff x="0" y="0"/>
-          <a:chExt cx="0" cy="0"/>
-        </a:xfrm>
-      </p:grpSpPr>
-      <p:sp>
-        <p:nvSpPr>
-          <p:cNvPr id="2" name="Slide Image Placeholder 1"/>
-          <p:cNvSpPr>
-            <a:spLocks noGrp="1" noRot="1" noChangeAspect="1"/>
-          </p:cNvSpPr>
-          <p:nvPr>
-            <p:ph type="sldImg"/>
-          </p:nvPr>
-        </p:nvSpPr>
-        <p:spPr/>
-      </p:sp>
-      <p:sp>
-        <p:nvSpPr>
-          <p:cNvPr id="3" name="Notes Placeholder 2"/>
-          <p:cNvSpPr>
-            <a:spLocks noGrp="1"/>
-          </p:cNvSpPr>
-          <p:nvPr>
-            <p:ph type="body" idx="1"/>
-          </p:nvPr>
-        </p:nvSpPr>
-        <p:spPr/>
-        <p:txBody>
-          <a:bodyPr/>
-          <a:lstStyle/>
-          <a:p>
-            <a:r>
-              <a:rPr lang="en-US" dirty="0"/>
-              <a:t>TIME 0:07-0:10
-FACILITATOR: Introduce the five steps and point out the three human decision gates. Participants can navigate back to completed steps; future steps stay locked until reached.
-CHECK: Ask the room which step prevents a poor interpretation from becoming an agent. Expected answer: the MVP confirmation gate.</a:t>
-            </a:r>
-            <a:endParaRPr lang="en-US" dirty="0"/>
-          </a:p>
-        </p:txBody>
-      </p:sp>
-      <p:sp>
-        <p:nvSpPr>
-          <p:cNvPr id="4" name="Slide Number Placeholder 3"/>
-          <p:cNvSpPr>
-            <a:spLocks noGrp="1"/>
-          </p:cNvSpPr>
-          <p:nvPr>
-            <p:ph type="sldNum" sz="quarter" idx="10"/>
-          </p:nvPr>
-        </p:nvSpPr>
-        <p:spPr/>
-        <p:txBody>
-          <a:bodyPr/>
-          <a:lstStyle/>
-          <a:p>
-            <a:fld id="{F7021451-1387-4CA6-816F-3879F97B5CBC}" type="slidenum">
-              <a:rPr lang="en-US"/>
-              <a:t>5</a:t>
-            </a:fld>
-            <a:endParaRPr lang="en-US"/>
-          </a:p>
-        </p:txBody>
-      </p:sp>
-    </p:spTree>
-    <p:extLst>
-      <p:ext uri="{BB962C8B-B14F-4D97-AF65-F5344CB8AC3E}">
-        <p14:creationId xmlns:p14="http://schemas.microsoft.com/office/powerpoint/2010/main" val="1024086991"/>
-      </p:ext>
-    </p:extLst>
-  </p:cSld>
-  <p:clrMapOvr>
-    <a:masterClrMapping/>
-  </p:clrMapOvr>
-</p:notes>
-</file>
-
-<file path=ppt/notesSlides/notesSlide6.xml><?xml version="1.0" encoding="utf-8"?>
-<p:notes xmlns:a="http://schemas.openxmlformats.org/drawingml/2006/main" xmlns:r="http://schemas.openxmlformats.org/officeDocument/2006/relationships" xmlns:p="http://schemas.openxmlformats.org/presentationml/2006/main">
-  <p:cSld>
-    <p:spTree>
-      <p:nvGrpSpPr>
-        <p:cNvPr id="1" name=""/>
-        <p:cNvGrpSpPr/>
-        <p:nvPr/>
-      </p:nvGrpSpPr>
-      <p:grpSpPr>
-        <a:xfrm>
-          <a:off x="0" y="0"/>
-          <a:ext cx="0" cy="0"/>
-          <a:chOff x="0" y="0"/>
-          <a:chExt cx="0" cy="0"/>
-        </a:xfrm>
-      </p:grpSpPr>
-      <p:sp>
-        <p:nvSpPr>
-          <p:cNvPr id="2" name="Slide Image Placeholder 1"/>
-          <p:cNvSpPr>
-            <a:spLocks noGrp="1" noRot="1" noChangeAspect="1"/>
-          </p:cNvSpPr>
-          <p:nvPr>
-            <p:ph type="sldImg"/>
-          </p:nvPr>
-        </p:nvSpPr>
-        <p:spPr/>
-      </p:sp>
-      <p:sp>
-        <p:nvSpPr>
-          <p:cNvPr id="3" name="Notes Placeholder 2"/>
-          <p:cNvSpPr>
-            <a:spLocks noGrp="1"/>
-          </p:cNvSpPr>
-          <p:nvPr>
-            <p:ph type="body" idx="1"/>
-          </p:nvPr>
-        </p:nvSpPr>
-        <p:spPr/>
-        <p:txBody>
-          <a:bodyPr/>
-          <a:lstStyle/>
-          <a:p>
-            <a:r>
-              <a:rPr lang="en-US" dirty="0"/>
-              <a:t>TIME 0:10-0:15
-FACILITATOR: Read the transcript excerpt. Ask participants to identify the user, problem, desired outcome, and guardrail. Use this same scenario for the demonstration so the room sees one complete thread from input to deployed agent.
-PARTICIPANT: If using their own case, rewrite it into this same shape before continuing.</a:t>
-            </a:r>
-            <a:endParaRPr lang="en-US" dirty="0"/>
-          </a:p>
-        </p:txBody>
-      </p:sp>
-      <p:sp>
-        <p:nvSpPr>
-          <p:cNvPr id="4" name="Slide Number Placeholder 3"/>
-          <p:cNvSpPr>
-            <a:spLocks noGrp="1"/>
-          </p:cNvSpPr>
-          <p:nvPr>
-            <p:ph type="sldNum" sz="quarter" idx="10"/>
-          </p:nvPr>
-        </p:nvSpPr>
-        <p:spPr/>
-        <p:txBody>
-          <a:bodyPr/>
-          <a:lstStyle/>
-          <a:p>
-            <a:fld id="{F7021451-1387-4CA6-816F-3879F97B5CBC}" type="slidenum">
-              <a:rPr lang="en-US"/>
-              <a:t>6</a:t>
-            </a:fld>
-            <a:endParaRPr lang="en-US"/>
-          </a:p>
-        </p:txBody>
-      </p:sp>
-    </p:spTree>
-    <p:extLst>
-      <p:ext uri="{BB962C8B-B14F-4D97-AF65-F5344CB8AC3E}">
-        <p14:creationId xmlns:p14="http://schemas.microsoft.com/office/powerpoint/2010/main" val="1024086991"/>
-      </p:ext>
-    </p:extLst>
-  </p:cSld>
-  <p:clrMapOvr>
-    <a:masterClrMapping/>
-  </p:clrMapOvr>
-</p:notes>
-</file>
-
-<file path=ppt/notesSlides/notesSlide7.xml><?xml version="1.0" encoding="utf-8"?>
-<p:notes xmlns:a="http://schemas.openxmlformats.org/drawingml/2006/main" xmlns:r="http://schemas.openxmlformats.org/officeDocument/2006/relationships" xmlns:p="http://schemas.openxmlformats.org/presentationml/2006/main">
-  <p:cSld>
-    <p:spTree>
-      <p:nvGrpSpPr>
-        <p:cNvPr id="1" name=""/>
-        <p:cNvGrpSpPr/>
-        <p:nvPr/>
-      </p:nvGrpSpPr>
-      <p:grpSpPr>
-        <a:xfrm>
-          <a:off x="0" y="0"/>
-          <a:ext cx="0" cy="0"/>
-          <a:chOff x="0" y="0"/>
-          <a:chExt cx="0" cy="0"/>
-        </a:xfrm>
-      </p:grpSpPr>
-      <p:sp>
-        <p:nvSpPr>
-          <p:cNvPr id="2" name="Slide Image Placeholder 1"/>
-          <p:cNvSpPr>
-            <a:spLocks noGrp="1" noRot="1" noChangeAspect="1"/>
-          </p:cNvSpPr>
-          <p:nvPr>
-            <p:ph type="sldImg"/>
-          </p:nvPr>
-        </p:nvSpPr>
-        <p:spPr/>
-      </p:sp>
-      <p:sp>
-        <p:nvSpPr>
-          <p:cNvPr id="3" name="Notes Placeholder 2"/>
-          <p:cNvSpPr>
-            <a:spLocks noGrp="1"/>
-          </p:cNvSpPr>
-          <p:nvPr>
-            <p:ph type="body" idx="1"/>
-          </p:nvPr>
-        </p:nvSpPr>
-        <p:spPr/>
-        <p:txBody>
-          <a:bodyPr/>
-          <a:lstStyle/>
-          <a:p>
-            <a:r>
-              <a:rPr lang="en-US" dirty="0"/>
-              <a:t>TIME 0:15-0:18
-FACILITATOR: Answer the common input question precisely. Narrative can arrive in many supported document formats, but the current workshop uploader does not accept PNG or JPG directly. Convert image-only notes with OCR or place the recognized text into PDF or DOCX.
-DATA: Uploaded content is processed by Azure OpenAI and screened by Azure AI Content Safety. Participants must use only information they are permitted to process.</a:t>
-            </a:r>
-            <a:endParaRPr lang="en-US" dirty="0"/>
-          </a:p>
-        </p:txBody>
-      </p:sp>
-      <p:sp>
-        <p:nvSpPr>
-          <p:cNvPr id="4" name="Slide Number Placeholder 3"/>
-          <p:cNvSpPr>
-            <a:spLocks noGrp="1"/>
-          </p:cNvSpPr>
-          <p:nvPr>
-            <p:ph type="sldNum" sz="quarter" idx="10"/>
-          </p:nvPr>
-        </p:nvSpPr>
-        <p:spPr/>
-        <p:txBody>
-          <a:bodyPr/>
-          <a:lstStyle/>
-          <a:p>
-            <a:fld id="{F7021451-1387-4CA6-816F-3879F97B5CBC}" type="slidenum">
-              <a:rPr lang="en-US"/>
-              <a:t>7</a:t>
-            </a:fld>
-            <a:endParaRPr lang="en-US"/>
-          </a:p>
-        </p:txBody>
-      </p:sp>
-    </p:spTree>
-    <p:extLst>
-      <p:ext uri="{BB962C8B-B14F-4D97-AF65-F5344CB8AC3E}">
-        <p14:creationId xmlns:p14="http://schemas.microsoft.com/office/powerpoint/2010/main" val="1024086991"/>
-      </p:ext>
-    </p:extLst>
-  </p:cSld>
-  <p:clrMapOvr>
-    <a:masterClrMapping/>
-  </p:clrMapOvr>
-</p:notes>
-</file>
-
-<file path=ppt/notesSlides/notesSlide8.xml><?xml version="1.0" encoding="utf-8"?>
-<p:notes xmlns:a="http://schemas.openxmlformats.org/drawingml/2006/main" xmlns:r="http://schemas.openxmlformats.org/officeDocument/2006/relationships" xmlns:p="http://schemas.openxmlformats.org/presentationml/2006/main">
-  <p:cSld>
-    <p:spTree>
-      <p:nvGrpSpPr>
-        <p:cNvPr id="1" name=""/>
-        <p:cNvGrpSpPr/>
-        <p:nvPr/>
-      </p:nvGrpSpPr>
-      <p:grpSpPr>
-        <a:xfrm>
-          <a:off x="0" y="0"/>
-          <a:ext cx="0" cy="0"/>
-          <a:chOff x="0" y="0"/>
-          <a:chExt cx="0" cy="0"/>
-        </a:xfrm>
-      </p:grpSpPr>
-      <p:sp>
-        <p:nvSpPr>
-          <p:cNvPr id="2" name="Slide Image Placeholder 1"/>
-          <p:cNvSpPr>
-            <a:spLocks noGrp="1" noRot="1" noChangeAspect="1"/>
-          </p:cNvSpPr>
-          <p:nvPr>
-            <p:ph type="sldImg"/>
-          </p:nvPr>
-        </p:nvSpPr>
-        <p:spPr/>
-      </p:sp>
-      <p:sp>
-        <p:nvSpPr>
-          <p:cNvPr id="3" name="Notes Placeholder 2"/>
-          <p:cNvSpPr>
-            <a:spLocks noGrp="1"/>
-          </p:cNvSpPr>
-          <p:nvPr>
-            <p:ph type="body" idx="1"/>
-          </p:nvPr>
-        </p:nvSpPr>
-        <p:spPr/>
-        <p:txBody>
-          <a:bodyPr/>
-          <a:lstStyle/>
-          <a:p>
-            <a:r>
-              <a:rPr lang="en-US" dirty="0"/>
-              <a:t>TIME 0:18-0:21
-FACILITATOR: Ask everyone to sign in. Generation requires a signed-in Entra ID account. Deployment also requires access to an operator-tenant Dataverse environment.
-WATCH FOR: Popup blocking, signing into the wrong tenant, or no maker role. Pair a blocked participant with a working driver while the facilitator resolves access.</a:t>
-            </a:r>
-            <a:endParaRPr lang="en-US" dirty="0"/>
-          </a:p>
-        </p:txBody>
-      </p:sp>
-      <p:sp>
-        <p:nvSpPr>
-          <p:cNvPr id="4" name="Slide Number Placeholder 3"/>
-          <p:cNvSpPr>
-            <a:spLocks noGrp="1"/>
-          </p:cNvSpPr>
-          <p:nvPr>
-            <p:ph type="sldNum" sz="quarter" idx="10"/>
-          </p:nvPr>
-        </p:nvSpPr>
-        <p:spPr/>
-        <p:txBody>
-          <a:bodyPr/>
-          <a:lstStyle/>
-          <a:p>
-            <a:fld id="{F7021451-1387-4CA6-816F-3879F97B5CBC}" type="slidenum">
-              <a:rPr lang="en-US"/>
-              <a:t>8</a:t>
-            </a:fld>
-            <a:endParaRPr lang="en-US"/>
-          </a:p>
-        </p:txBody>
-      </p:sp>
-    </p:spTree>
-    <p:extLst>
-      <p:ext uri="{BB962C8B-B14F-4D97-AF65-F5344CB8AC3E}">
-        <p14:creationId xmlns:p14="http://schemas.microsoft.com/office/powerpoint/2010/main" val="1024086991"/>
-      </p:ext>
-    </p:extLst>
-  </p:cSld>
-  <p:clrMapOvr>
-    <a:masterClrMapping/>
-  </p:clrMapOvr>
-</p:notes>
-</file>
-
-<file path=ppt/notesSlides/notesSlide9.xml><?xml version="1.0" encoding="utf-8"?>
-<p:notes xmlns:a="http://schemas.openxmlformats.org/drawingml/2006/main" xmlns:r="http://schemas.openxmlformats.org/officeDocument/2006/relationships" xmlns:p="http://schemas.openxmlformats.org/presentationml/2006/main">
-  <p:cSld>
-    <p:spTree>
-      <p:nvGrpSpPr>
-        <p:cNvPr id="1" name=""/>
-        <p:cNvGrpSpPr/>
-        <p:nvPr/>
-      </p:nvGrpSpPr>
-      <p:grpSpPr>
-        <a:xfrm>
-          <a:off x="0" y="0"/>
-          <a:ext cx="0" cy="0"/>
-          <a:chOff x="0" y="0"/>
-          <a:chExt cx="0" cy="0"/>
-        </a:xfrm>
-      </p:grpSpPr>
-      <p:sp>
-        <p:nvSpPr>
-          <p:cNvPr id="2" name="Slide Image Placeholder 1"/>
-          <p:cNvSpPr>
-            <a:spLocks noGrp="1" noRot="1" noChangeAspect="1"/>
-          </p:cNvSpPr>
-          <p:nvPr>
-            <p:ph type="sldImg"/>
-          </p:nvPr>
-        </p:nvSpPr>
-        <p:spPr/>
-      </p:sp>
-      <p:sp>
-        <p:nvSpPr>
-          <p:cNvPr id="3" name="Notes Placeholder 2"/>
-          <p:cNvSpPr>
-            <a:spLocks noGrp="1"/>
-          </p:cNvSpPr>
-          <p:nvPr>
-            <p:ph type="body" idx="1"/>
-          </p:nvPr>
-        </p:nvSpPr>
-        <p:spPr/>
-        <p:txBody>
-          <a:bodyPr/>
-          <a:lstStyle/>
-          <a:p>
-            <a:r>
-              <a:rPr lang="en-US" dirty="0"/>
-              <a:t>TIME 0:21-0:26
-FACILITATOR: Have participants upload the scenario transcript and any supporting evidence. The solution name is optional; if omitted, RAPP names it from the MVP.
-DO: Ask participants to say what each file contributes. Remove anything that does not help the MVP.
-DATA NOTICE: Files are sent to Azure OpenAI for capability identification and screened by Azure AI Content Safety.</a:t>
-            </a:r>
-            <a:endParaRPr lang="en-US" dirty="0"/>
-          </a:p>
-        </p:txBody>
-      </p:sp>
-      <p:sp>
-        <p:nvSpPr>
-          <p:cNvPr id="4" name="Slide Number Placeholder 3"/>
-          <p:cNvSpPr>
-            <a:spLocks noGrp="1"/>
-          </p:cNvSpPr>
-          <p:nvPr>
-            <p:ph type="sldNum" sz="quarter" idx="10"/>
-          </p:nvPr>
-        </p:nvSpPr>
-        <p:spPr/>
-        <p:txBody>
-          <a:bodyPr/>
-          <a:lstStyle/>
-          <a:p>
-            <a:fld id="{F7021451-1387-4CA6-816F-3879F97B5CBC}" type="slidenum">
-              <a:rPr lang="en-US"/>
-              <a:t>9</a:t>
-            </a:fld>
-            <a:endParaRPr lang="en-US"/>
-          </a:p>
-        </p:txBody>
-      </p:sp>
-    </p:spTree>
-    <p:extLst>
-      <p:ext uri="{BB962C8B-B14F-4D97-AF65-F5344CB8AC3E}">
-        <p14:creationId xmlns:p14="http://schemas.microsoft.com/office/powerpoint/2010/main" val="1024086991"/>
-      </p:ext>
-    </p:extLst>
-  </p:cSld>
-  <p:clrMapOvr>
-    <a:masterClrMapping/>
-  </p:clrMapOvr>
-</p:notes>
-</file>
-
 <file path=ppt/slideLayouts/slideLayout1.xml><?xml version="1.0" encoding="utf-8"?>
 <p:sldLayout xmlns:a="http://schemas.openxmlformats.org/drawingml/2006/main" xmlns:r="http://schemas.openxmlformats.org/officeDocument/2006/relationships" xmlns:p="http://schemas.openxmlformats.org/presentationml/2006/main" preserve="1">
   <p:cSld name="DEFAULT">
@@ -18224,7 +15894,7 @@
                 <a:ea typeface="Segoe UI" pitchFamily="34" charset="-122"/>
                 <a:cs typeface="Segoe UI" pitchFamily="34" charset="-120"/>
               </a:rPr>
-              <a:t xml:space="preserve">  Deck with speaker notes</a:t>
+              <a:t xml:space="preserve">  Deck + facilitator guide</a:t>
             </a:r>
             <a:endParaRPr lang="en-US" sz="1320" dirty="0"/>
           </a:p>
@@ -27462,7 +25132,7 @@
         <p:spPr>
           <a:xfrm>
             <a:off x="3378708" y="2286000"/>
-            <a:ext cx="1450848" cy="914400"/>
+            <a:ext cx="1994916" cy="914400"/>
           </a:xfrm>
           <a:prstGeom prst="rect">
             <a:avLst/>
@@ -27487,7 +25157,7 @@
         <p:spPr>
           <a:xfrm>
             <a:off x="3424428" y="2459736"/>
-            <a:ext cx="1359408" cy="173736"/>
+            <a:ext cx="1903476" cy="173736"/>
           </a:xfrm>
           <a:prstGeom prst="rect">
             <a:avLst/>
@@ -27513,7 +25183,7 @@
                 <a:ea typeface="Segoe UI Semibold" pitchFamily="34" charset="-122"/>
                 <a:cs typeface="Segoe UI Semibold" pitchFamily="34" charset="-120"/>
               </a:rPr>
-              <a:t>15-23</a:t>
+              <a:t>15-26</a:t>
             </a:r>
             <a:endParaRPr lang="en-US" sz="1100" dirty="0"/>
           </a:p>
@@ -27528,7 +25198,7 @@
         <p:spPr>
           <a:xfrm>
             <a:off x="3424428" y="2724912"/>
-            <a:ext cx="1359408" cy="173736"/>
+            <a:ext cx="1903476" cy="173736"/>
           </a:xfrm>
           <a:prstGeom prst="rect">
             <a:avLst/>
@@ -27568,7 +25238,7 @@
         </p:nvSpPr>
         <p:spPr>
           <a:xfrm>
-            <a:off x="4829556" y="2286000"/>
+            <a:off x="5373624" y="2286000"/>
             <a:ext cx="1450848" cy="914400"/>
           </a:xfrm>
           <a:prstGeom prst="rect">
@@ -27593,7 +25263,7 @@
         </p:nvSpPr>
         <p:spPr>
           <a:xfrm>
-            <a:off x="4875276" y="2459736"/>
+            <a:off x="5419344" y="2459736"/>
             <a:ext cx="1359408" cy="173736"/>
           </a:xfrm>
           <a:prstGeom prst="rect">
@@ -27620,7 +25290,7 @@
                 <a:ea typeface="Segoe UI Semibold" pitchFamily="34" charset="-122"/>
                 <a:cs typeface="Segoe UI Semibold" pitchFamily="34" charset="-120"/>
               </a:rPr>
-              <a:t>23-31</a:t>
+              <a:t>26-34</a:t>
             </a:r>
             <a:endParaRPr lang="en-US" sz="1100" dirty="0"/>
           </a:p>
@@ -27634,7 +25304,7 @@
         </p:nvSpPr>
         <p:spPr>
           <a:xfrm>
-            <a:off x="4875276" y="2724912"/>
+            <a:off x="5419344" y="2724912"/>
             <a:ext cx="1359408" cy="173736"/>
           </a:xfrm>
           <a:prstGeom prst="rect">
@@ -27675,7 +25345,7 @@
         </p:nvSpPr>
         <p:spPr>
           <a:xfrm>
-            <a:off x="6280404" y="2286000"/>
+            <a:off x="6824472" y="2286000"/>
             <a:ext cx="1813560" cy="914400"/>
           </a:xfrm>
           <a:prstGeom prst="rect">
@@ -27700,7 +25370,7 @@
         </p:nvSpPr>
         <p:spPr>
           <a:xfrm>
-            <a:off x="6326124" y="2459736"/>
+            <a:off x="6870192" y="2459736"/>
             <a:ext cx="1722120" cy="173736"/>
           </a:xfrm>
           <a:prstGeom prst="rect">
@@ -27727,7 +25397,7 @@
                 <a:ea typeface="Segoe UI Semibold" pitchFamily="34" charset="-122"/>
                 <a:cs typeface="Segoe UI Semibold" pitchFamily="34" charset="-120"/>
               </a:rPr>
-              <a:t>31-41</a:t>
+              <a:t>34-44</a:t>
             </a:r>
             <a:endParaRPr lang="en-US" sz="1100" dirty="0"/>
           </a:p>
@@ -27741,7 +25411,7 @@
         </p:nvSpPr>
         <p:spPr>
           <a:xfrm>
-            <a:off x="6326124" y="2724912"/>
+            <a:off x="6870192" y="2724912"/>
             <a:ext cx="1722120" cy="173736"/>
           </a:xfrm>
           <a:prstGeom prst="rect">
@@ -27782,8 +25452,8 @@
         </p:nvSpPr>
         <p:spPr>
           <a:xfrm>
-            <a:off x="8093964" y="2286000"/>
-            <a:ext cx="1813560" cy="914400"/>
+            <a:off x="8638032" y="2286000"/>
+            <a:ext cx="1450848" cy="914400"/>
           </a:xfrm>
           <a:prstGeom prst="rect">
             <a:avLst/>
@@ -27807,8 +25477,8 @@
         </p:nvSpPr>
         <p:spPr>
           <a:xfrm>
-            <a:off x="8139684" y="2459736"/>
-            <a:ext cx="1722120" cy="173736"/>
+            <a:off x="8683752" y="2459736"/>
+            <a:ext cx="1359408" cy="173736"/>
           </a:xfrm>
           <a:prstGeom prst="rect">
             <a:avLst/>
@@ -27834,7 +25504,7 @@
                 <a:ea typeface="Segoe UI Semibold" pitchFamily="34" charset="-122"/>
                 <a:cs typeface="Segoe UI Semibold" pitchFamily="34" charset="-120"/>
               </a:rPr>
-              <a:t>41-51</a:t>
+              <a:t>44-52</a:t>
             </a:r>
             <a:endParaRPr lang="en-US" sz="1100" dirty="0"/>
           </a:p>
@@ -27848,8 +25518,8 @@
         </p:nvSpPr>
         <p:spPr>
           <a:xfrm>
-            <a:off x="8139684" y="2724912"/>
-            <a:ext cx="1722120" cy="173736"/>
+            <a:off x="8683752" y="2724912"/>
+            <a:ext cx="1359408" cy="173736"/>
           </a:xfrm>
           <a:prstGeom prst="rect">
             <a:avLst/>
@@ -27889,8 +25559,8 @@
         </p:nvSpPr>
         <p:spPr>
           <a:xfrm>
-            <a:off x="9907524" y="2286000"/>
-            <a:ext cx="1088136" cy="914400"/>
+            <a:off x="10088880" y="2286000"/>
+            <a:ext cx="725424" cy="914400"/>
           </a:xfrm>
           <a:prstGeom prst="rect">
             <a:avLst/>
@@ -27914,8 +25584,8 @@
         </p:nvSpPr>
         <p:spPr>
           <a:xfrm>
-            <a:off x="9953244" y="2459736"/>
-            <a:ext cx="996696" cy="173736"/>
+            <a:off x="10134600" y="2459736"/>
+            <a:ext cx="633984" cy="173736"/>
           </a:xfrm>
           <a:prstGeom prst="rect">
             <a:avLst/>
@@ -27933,7 +25603,7 @@
               <a:buNone/>
             </a:pPr>
             <a:r>
-              <a:rPr lang="en-US" sz="1100" b="1" dirty="0">
+              <a:rPr lang="en-US" sz="850" b="1" dirty="0">
                 <a:solidFill>
                   <a:srgbClr val="FFFFFF"/>
                 </a:solidFill>
@@ -27941,9 +25611,9 @@
                 <a:ea typeface="Segoe UI Semibold" pitchFamily="34" charset="-122"/>
                 <a:cs typeface="Segoe UI Semibold" pitchFamily="34" charset="-120"/>
               </a:rPr>
-              <a:t>51-57</a:t>
-            </a:r>
-            <a:endParaRPr lang="en-US" sz="1100" dirty="0"/>
+              <a:t>52-56</a:t>
+            </a:r>
+            <a:endParaRPr lang="en-US" sz="850" dirty="0"/>
           </a:p>
         </p:txBody>
       </p:sp>
@@ -27955,8 +25625,8 @@
         </p:nvSpPr>
         <p:spPr>
           <a:xfrm>
-            <a:off x="9953244" y="2724912"/>
-            <a:ext cx="996696" cy="173736"/>
+            <a:off x="10134600" y="2724912"/>
+            <a:ext cx="633984" cy="173736"/>
           </a:xfrm>
           <a:prstGeom prst="rect">
             <a:avLst/>
@@ -27974,7 +25644,7 @@
               <a:buNone/>
             </a:pPr>
             <a:r>
-              <a:rPr lang="en-US" sz="880" b="1" dirty="0">
+              <a:rPr lang="en-US" sz="750" b="1" dirty="0">
                 <a:solidFill>
                   <a:srgbClr val="DCEEFF"/>
                 </a:solidFill>
@@ -27984,7 +25654,7 @@
               </a:rPr>
               <a:t>TEST</a:t>
             </a:r>
-            <a:endParaRPr lang="en-US" sz="880" dirty="0"/>
+            <a:endParaRPr lang="en-US" sz="750" dirty="0"/>
           </a:p>
         </p:txBody>
       </p:sp>
@@ -27996,8 +25666,8 @@
         </p:nvSpPr>
         <p:spPr>
           <a:xfrm>
-            <a:off x="10995660" y="2286000"/>
-            <a:ext cx="544068" cy="914400"/>
+            <a:off x="10814304" y="2286000"/>
+            <a:ext cx="725424" cy="914400"/>
           </a:xfrm>
           <a:prstGeom prst="roundRect">
             <a:avLst/>
@@ -28021,8 +25691,8 @@
         </p:nvSpPr>
         <p:spPr>
           <a:xfrm>
-            <a:off x="11041380" y="2459736"/>
-            <a:ext cx="452628" cy="173736"/>
+            <a:off x="10860024" y="2459736"/>
+            <a:ext cx="633984" cy="173736"/>
           </a:xfrm>
           <a:prstGeom prst="rect">
             <a:avLst/>
@@ -28048,7 +25718,7 @@
                 <a:ea typeface="Segoe UI Semibold" pitchFamily="34" charset="-122"/>
                 <a:cs typeface="Segoe UI Semibold" pitchFamily="34" charset="-120"/>
               </a:rPr>
-              <a:t>57-60</a:t>
+              <a:t>56-60</a:t>
             </a:r>
             <a:endParaRPr lang="en-US" sz="850" dirty="0"/>
           </a:p>
@@ -28062,8 +25732,8 @@
         </p:nvSpPr>
         <p:spPr>
           <a:xfrm>
-            <a:off x="11041380" y="2724912"/>
-            <a:ext cx="452628" cy="173736"/>
+            <a:off x="10860024" y="2724912"/>
+            <a:ext cx="633984" cy="173736"/>
           </a:xfrm>
           <a:prstGeom prst="rect">
             <a:avLst/>
@@ -28160,7 +25830,7 @@
                 <a:ea typeface="Segoe UI Semibold" pitchFamily="34" charset="-122"/>
                 <a:cs typeface="Segoe UI Semibold" pitchFamily="34" charset="-120"/>
               </a:rPr>
-              <a:t>15</a:t>
+              <a:t>26</a:t>
             </a:r>
             <a:endParaRPr lang="en-US" sz="2500" dirty="0"/>
           </a:p>
@@ -28242,7 +25912,7 @@
                 <a:ea typeface="Segoe UI" pitchFamily="34" charset="-122"/>
                 <a:cs typeface="Segoe UI" pitchFamily="34" charset="-120"/>
               </a:rPr>
-              <a:t>One clear scenario</a:t>
+              <a:t>Source set accepted</a:t>
             </a:r>
             <a:endParaRPr lang="en-US" sz="1050" dirty="0"/>
           </a:p>
@@ -28313,7 +25983,7 @@
                 <a:ea typeface="Segoe UI Semibold" pitchFamily="34" charset="-122"/>
                 <a:cs typeface="Segoe UI Semibold" pitchFamily="34" charset="-120"/>
               </a:rPr>
-              <a:t>31</a:t>
+              <a:t>34</a:t>
             </a:r>
             <a:endParaRPr lang="en-US" sz="2500" dirty="0"/>
           </a:p>
@@ -28466,7 +26136,7 @@
                 <a:ea typeface="Segoe UI Semibold" pitchFamily="34" charset="-122"/>
                 <a:cs typeface="Segoe UI Semibold" pitchFamily="34" charset="-120"/>
               </a:rPr>
-              <a:t>41</a:t>
+              <a:t>44</a:t>
             </a:r>
             <a:endParaRPr lang="en-US" sz="2500" dirty="0"/>
           </a:p>
@@ -28619,7 +26289,7 @@
                 <a:ea typeface="Segoe UI Semibold" pitchFamily="34" charset="-122"/>
                 <a:cs typeface="Segoe UI Semibold" pitchFamily="34" charset="-120"/>
               </a:rPr>
-              <a:t>57</a:t>
+              <a:t>56</a:t>
             </a:r>
             <a:endParaRPr lang="en-US" sz="2500" dirty="0"/>
           </a:p>

</xml_diff>